<commit_message>
updated documents to match the latest status of the codebase
</commit_message>
<xml_diff>
--- a/docs/presentation/Risk_Assessment_Workbench_Genius_Hacks_2026.pptx
+++ b/docs/presentation/Risk_Assessment_Workbench_Genius_Hacks_2026.pptx
@@ -11599,7 +11599,7 @@
                 </a:solidFill>
                 <a:latin typeface="Aptos"/>
               </a:rPr>
-              <a:t>Prototype limitation: demo headers are not production identity; quorum is a next increment.</a:t>
+              <a:t>Prototype limitation: demo headers are not production identity; database immutability and decision policy remain.</a:t>
             </a:r>
           </a:p>
         </p:txBody>
@@ -12906,7 +12906,7 @@
                 </a:solidFill>
                 <a:latin typeface="Aptos"/>
               </a:rPr>
-              <a:t>66.2%</a:t>
+              <a:t>0/8</a:t>
             </a:r>
           </a:p>
         </p:txBody>
@@ -12941,7 +12941,7 @@
                 </a:solidFill>
                 <a:latin typeface="Aptos"/>
               </a:rPr>
-              <a:t>normalized field accuracy</a:t>
+              <a:t>latest live calls succeeded</a:t>
             </a:r>
           </a:p>
         </p:txBody>
@@ -12976,7 +12976,7 @@
                 </a:solidFill>
                 <a:latin typeface="Aptos"/>
               </a:rPr>
-              <a:t>87.5%</a:t>
+              <a:t>N/A</a:t>
             </a:r>
           </a:p>
         </p:txBody>
@@ -13011,7 +13011,7 @@
                 </a:solidFill>
                 <a:latin typeface="Aptos"/>
               </a:rPr>
-              <a:t>risk-level agreement</a:t>
+              <a:t>quality metrics unavailable</a:t>
             </a:r>
           </a:p>
         </p:txBody>
@@ -13046,7 +13046,7 @@
                 </a:solidFill>
                 <a:latin typeface="Aptos"/>
               </a:rPr>
-              <a:t>19</a:t>
+              <a:t>24</a:t>
             </a:r>
           </a:p>
         </p:txBody>

</xml_diff>

<commit_message>
updated the presentation file for minor adjustments, UI only
</commit_message>
<xml_diff>
--- a/docs/presentation/Risk_Assessment_Workbench_Genius_Hacks_2026.pptx
+++ b/docs/presentation/Risk_Assessment_Workbench_Genius_Hacks_2026.pptx
@@ -5,20 +5,20 @@
     <p:sldMasterId id="2147483648" r:id="rId1"/>
   </p:sldMasterIdLst>
   <p:sldIdLst>
-    <p:sldId id="256" r:id="rId7"/>
-    <p:sldId id="257" r:id="rId8"/>
-    <p:sldId id="258" r:id="rId9"/>
-    <p:sldId id="259" r:id="rId10"/>
-    <p:sldId id="260" r:id="rId11"/>
-    <p:sldId id="261" r:id="rId12"/>
-    <p:sldId id="262" r:id="rId13"/>
-    <p:sldId id="263" r:id="rId14"/>
-    <p:sldId id="264" r:id="rId15"/>
-    <p:sldId id="265" r:id="rId16"/>
-    <p:sldId id="266" r:id="rId17"/>
-    <p:sldId id="267" r:id="rId18"/>
+    <p:sldId id="256" r:id="rId2"/>
+    <p:sldId id="257" r:id="rId3"/>
+    <p:sldId id="258" r:id="rId4"/>
+    <p:sldId id="259" r:id="rId5"/>
+    <p:sldId id="260" r:id="rId6"/>
+    <p:sldId id="261" r:id="rId7"/>
+    <p:sldId id="262" r:id="rId8"/>
+    <p:sldId id="263" r:id="rId9"/>
+    <p:sldId id="264" r:id="rId10"/>
+    <p:sldId id="265" r:id="rId11"/>
+    <p:sldId id="266" r:id="rId12"/>
+    <p:sldId id="267" r:id="rId13"/>
   </p:sldIdLst>
-  <p:sldSz cx="12191695" cy="6858000" type="screen4x3"/>
+  <p:sldSz cx="12192000" cy="6858000"/>
   <p:notesSz cx="6858000" cy="9144000"/>
   <p:defaultTextStyle>
     <a:defPPr>
@@ -299,7 +299,7 @@
           <a:p>
             <a:fld id="{5BCAD085-E8A6-8845-BD4E-CB4CCA059FC4}" type="datetimeFigureOut">
               <a:rPr lang="en-US" smtClean="0"/>
-              <a:t>1/27/13</a:t>
+              <a:t>9/28/2026</a:t>
             </a:fld>
             <a:endParaRPr lang="en-US"/>
           </a:p>
@@ -469,7 +469,7 @@
           <a:p>
             <a:fld id="{5BCAD085-E8A6-8845-BD4E-CB4CCA059FC4}" type="datetimeFigureOut">
               <a:rPr lang="en-US" smtClean="0"/>
-              <a:t>1/27/13</a:t>
+              <a:t>9/28/2026</a:t>
             </a:fld>
             <a:endParaRPr lang="en-US"/>
           </a:p>
@@ -649,7 +649,7 @@
           <a:p>
             <a:fld id="{5BCAD085-E8A6-8845-BD4E-CB4CCA059FC4}" type="datetimeFigureOut">
               <a:rPr lang="en-US" smtClean="0"/>
-              <a:t>1/27/13</a:t>
+              <a:t>9/28/2026</a:t>
             </a:fld>
             <a:endParaRPr lang="en-US"/>
           </a:p>
@@ -819,7 +819,7 @@
           <a:p>
             <a:fld id="{5BCAD085-E8A6-8845-BD4E-CB4CCA059FC4}" type="datetimeFigureOut">
               <a:rPr lang="en-US" smtClean="0"/>
-              <a:t>1/27/13</a:t>
+              <a:t>9/28/2026</a:t>
             </a:fld>
             <a:endParaRPr lang="en-US"/>
           </a:p>
@@ -1065,7 +1065,7 @@
           <a:p>
             <a:fld id="{5BCAD085-E8A6-8845-BD4E-CB4CCA059FC4}" type="datetimeFigureOut">
               <a:rPr lang="en-US" smtClean="0"/>
-              <a:t>1/27/13</a:t>
+              <a:t>9/28/2026</a:t>
             </a:fld>
             <a:endParaRPr lang="en-US"/>
           </a:p>
@@ -1353,7 +1353,7 @@
           <a:p>
             <a:fld id="{5BCAD085-E8A6-8845-BD4E-CB4CCA059FC4}" type="datetimeFigureOut">
               <a:rPr lang="en-US" smtClean="0"/>
-              <a:t>1/27/13</a:t>
+              <a:t>9/28/2026</a:t>
             </a:fld>
             <a:endParaRPr lang="en-US"/>
           </a:p>
@@ -1775,7 +1775,7 @@
           <a:p>
             <a:fld id="{5BCAD085-E8A6-8845-BD4E-CB4CCA059FC4}" type="datetimeFigureOut">
               <a:rPr lang="en-US" smtClean="0"/>
-              <a:t>1/27/13</a:t>
+              <a:t>9/28/2026</a:t>
             </a:fld>
             <a:endParaRPr lang="en-US"/>
           </a:p>
@@ -1893,7 +1893,7 @@
           <a:p>
             <a:fld id="{5BCAD085-E8A6-8845-BD4E-CB4CCA059FC4}" type="datetimeFigureOut">
               <a:rPr lang="en-US" smtClean="0"/>
-              <a:t>1/27/13</a:t>
+              <a:t>9/28/2026</a:t>
             </a:fld>
             <a:endParaRPr lang="en-US"/>
           </a:p>
@@ -1988,7 +1988,7 @@
           <a:p>
             <a:fld id="{5BCAD085-E8A6-8845-BD4E-CB4CCA059FC4}" type="datetimeFigureOut">
               <a:rPr lang="en-US" smtClean="0"/>
-              <a:t>1/27/13</a:t>
+              <a:t>9/28/2026</a:t>
             </a:fld>
             <a:endParaRPr lang="en-US"/>
           </a:p>
@@ -2265,7 +2265,7 @@
           <a:p>
             <a:fld id="{5BCAD085-E8A6-8845-BD4E-CB4CCA059FC4}" type="datetimeFigureOut">
               <a:rPr lang="en-US" smtClean="0"/>
-              <a:t>1/27/13</a:t>
+              <a:t>9/28/2026</a:t>
             </a:fld>
             <a:endParaRPr lang="en-US"/>
           </a:p>
@@ -2518,7 +2518,7 @@
           <a:p>
             <a:fld id="{5BCAD085-E8A6-8845-BD4E-CB4CCA059FC4}" type="datetimeFigureOut">
               <a:rPr lang="en-US" smtClean="0"/>
-              <a:t>1/27/13</a:t>
+              <a:t>9/28/2026</a:t>
             </a:fld>
             <a:endParaRPr lang="en-US"/>
           </a:p>
@@ -2731,7 +2731,7 @@
           <a:p>
             <a:fld id="{5BCAD085-E8A6-8845-BD4E-CB4CCA059FC4}" type="datetimeFigureOut">
               <a:rPr lang="en-US" smtClean="0"/>
-              <a:t>1/27/13</a:t>
+              <a:t>9/28/2026</a:t>
             </a:fld>
             <a:endParaRPr lang="en-US"/>
           </a:p>
@@ -3090,7 +3090,7 @@
 </file>
 
 <file path=ppt/slides/slide1.xml><?xml version="1.0" encoding="utf-8"?>
-<p:sld xmlns:a="http://schemas.openxmlformats.org/drawingml/2006/main" xmlns:p="http://schemas.openxmlformats.org/presentationml/2006/main" xmlns:r="http://schemas.openxmlformats.org/officeDocument/2006/relationships">
+<p:sld xmlns:a="http://schemas.openxmlformats.org/drawingml/2006/main" xmlns:r="http://schemas.openxmlformats.org/officeDocument/2006/relationships" xmlns:p="http://schemas.openxmlformats.org/presentationml/2006/main">
   <p:cSld>
     <p:bg>
       <p:bgPr>
@@ -3106,7 +3106,14 @@
         <p:cNvGrpSpPr/>
         <p:nvPr/>
       </p:nvGrpSpPr>
-      <p:grpSpPr/>
+      <p:grpSpPr>
+        <a:xfrm>
+          <a:off x="0" y="0"/>
+          <a:ext cx="0" cy="0"/>
+          <a:chOff x="0" y="0"/>
+          <a:chExt cx="0" cy="0"/>
+        </a:xfrm>
+      </p:grpSpPr>
       <p:sp>
         <p:nvSpPr>
           <p:cNvPr id="2" name="Rectangle 1"/>
@@ -3149,6 +3156,7 @@
           <a:lstStyle/>
           <a:p>
             <a:pPr algn="ctr"/>
+            <a:endParaRPr/>
           </a:p>
         </p:txBody>
       </p:sp>
@@ -3194,6 +3202,7 @@
           <a:lstStyle/>
           <a:p>
             <a:pPr algn="ctr"/>
+            <a:endParaRPr/>
           </a:p>
         </p:txBody>
       </p:sp>
@@ -3214,7 +3223,7 @@
           <a:noFill/>
         </p:spPr>
         <p:txBody>
-          <a:bodyPr wrap="square" lIns="36576" rIns="36576" tIns="18288" anchor="t">
+          <a:bodyPr wrap="square" lIns="36576" tIns="18288" rIns="36576" anchor="t">
             <a:spAutoFit/>
           </a:bodyPr>
           <a:lstStyle/>
@@ -3249,7 +3258,7 @@
           <a:noFill/>
         </p:spPr>
         <p:txBody>
-          <a:bodyPr wrap="square" lIns="36576" rIns="36576" tIns="18288" anchor="t">
+          <a:bodyPr wrap="square" lIns="36576" tIns="18288" rIns="36576" anchor="t">
             <a:spAutoFit/>
           </a:bodyPr>
           <a:lstStyle/>
@@ -3285,7 +3294,7 @@
           <a:noFill/>
         </p:spPr>
         <p:txBody>
-          <a:bodyPr wrap="square" lIns="36576" rIns="36576" tIns="18288" anchor="t">
+          <a:bodyPr wrap="square" lIns="36576" tIns="18288" rIns="36576" anchor="t">
             <a:spAutoFit/>
           </a:bodyPr>
           <a:lstStyle/>
@@ -3320,7 +3329,7 @@
           <a:noFill/>
         </p:spPr>
         <p:txBody>
-          <a:bodyPr wrap="square" lIns="36576" rIns="36576" tIns="18288" anchor="t">
+          <a:bodyPr wrap="square" lIns="36576" tIns="18288" rIns="36576" anchor="t">
             <a:spAutoFit/>
           </a:bodyPr>
           <a:lstStyle/>
@@ -3380,6 +3389,7 @@
           <a:lstStyle/>
           <a:p>
             <a:pPr algn="ctr"/>
+            <a:endParaRPr/>
           </a:p>
         </p:txBody>
       </p:sp>
@@ -3400,7 +3410,7 @@
           <a:noFill/>
         </p:spPr>
         <p:txBody>
-          <a:bodyPr wrap="square" lIns="36576" rIns="36576" tIns="18288" anchor="t">
+          <a:bodyPr wrap="square" lIns="36576" tIns="18288" rIns="36576" anchor="t">
             <a:spAutoFit/>
           </a:bodyPr>
           <a:lstStyle/>
@@ -3438,7 +3448,7 @@
           <a:noFill/>
         </p:spPr>
         <p:txBody>
-          <a:bodyPr wrap="square" lIns="36576" rIns="36576" tIns="18288" anchor="t">
+          <a:bodyPr wrap="square" lIns="36576" tIns="18288" rIns="36576" anchor="t">
             <a:spAutoFit/>
           </a:bodyPr>
           <a:lstStyle/>
@@ -3461,11 +3471,18 @@
   <p:clrMapOvr>
     <a:masterClrMapping/>
   </p:clrMapOvr>
+  <p:timing>
+    <p:tnLst>
+      <p:par>
+        <p:cTn id="1" dur="indefinite" restart="never" nodeType="tmRoot"/>
+      </p:par>
+    </p:tnLst>
+  </p:timing>
 </p:sld>
 </file>
 
 <file path=ppt/slides/slide10.xml><?xml version="1.0" encoding="utf-8"?>
-<p:sld xmlns:a="http://schemas.openxmlformats.org/drawingml/2006/main" xmlns:p="http://schemas.openxmlformats.org/presentationml/2006/main" xmlns:r="http://schemas.openxmlformats.org/officeDocument/2006/relationships">
+<p:sld xmlns:a="http://schemas.openxmlformats.org/drawingml/2006/main" xmlns:r="http://schemas.openxmlformats.org/officeDocument/2006/relationships" xmlns:p="http://schemas.openxmlformats.org/presentationml/2006/main">
   <p:cSld>
     <p:bg>
       <p:bgPr>
@@ -3481,7 +3498,14 @@
         <p:cNvGrpSpPr/>
         <p:nvPr/>
       </p:nvGrpSpPr>
-      <p:grpSpPr/>
+      <p:grpSpPr>
+        <a:xfrm>
+          <a:off x="0" y="0"/>
+          <a:ext cx="0" cy="0"/>
+          <a:chOff x="0" y="0"/>
+          <a:chExt cx="0" cy="0"/>
+        </a:xfrm>
+      </p:grpSpPr>
       <p:sp>
         <p:nvSpPr>
           <p:cNvPr id="2" name="Rectangle 1"/>
@@ -3524,6 +3548,7 @@
           <a:lstStyle/>
           <a:p>
             <a:pPr algn="ctr"/>
+            <a:endParaRPr/>
           </a:p>
         </p:txBody>
       </p:sp>
@@ -3544,7 +3569,7 @@
           <a:noFill/>
         </p:spPr>
         <p:txBody>
-          <a:bodyPr wrap="square" lIns="36576" rIns="36576" tIns="18288" anchor="t">
+          <a:bodyPr wrap="square" lIns="36576" tIns="18288" rIns="36576" anchor="t">
             <a:spAutoFit/>
           </a:bodyPr>
           <a:lstStyle/>
@@ -3579,7 +3604,7 @@
           <a:noFill/>
         </p:spPr>
         <p:txBody>
-          <a:bodyPr wrap="square" lIns="36576" rIns="36576" tIns="18288" anchor="t">
+          <a:bodyPr wrap="square" lIns="36576" tIns="18288" rIns="36576" anchor="t">
             <a:spAutoFit/>
           </a:bodyPr>
           <a:lstStyle/>
@@ -3614,7 +3639,7 @@
           <a:noFill/>
         </p:spPr>
         <p:txBody>
-          <a:bodyPr wrap="square" lIns="36576" rIns="36576" tIns="18288" anchor="t">
+          <a:bodyPr wrap="square" lIns="36576" tIns="18288" rIns="36576" anchor="t">
             <a:spAutoFit/>
           </a:bodyPr>
           <a:lstStyle/>
@@ -3649,7 +3674,7 @@
           <a:noFill/>
         </p:spPr>
         <p:txBody>
-          <a:bodyPr wrap="square" lIns="36576" rIns="36576" tIns="18288" anchor="t">
+          <a:bodyPr wrap="square" lIns="36576" tIns="18288" rIns="36576" anchor="t">
             <a:spAutoFit/>
           </a:bodyPr>
           <a:lstStyle/>
@@ -3709,6 +3734,7 @@
           <a:lstStyle/>
           <a:p>
             <a:pPr algn="ctr"/>
+            <a:endParaRPr/>
           </a:p>
         </p:txBody>
       </p:sp>
@@ -3754,6 +3780,7 @@
           <a:lstStyle/>
           <a:p>
             <a:pPr algn="ctr"/>
+            <a:endParaRPr/>
           </a:p>
         </p:txBody>
       </p:sp>
@@ -3774,7 +3801,7 @@
           <a:noFill/>
         </p:spPr>
         <p:txBody>
-          <a:bodyPr wrap="square" lIns="36576" rIns="36576" tIns="18288" anchor="t">
+          <a:bodyPr wrap="square" lIns="36576" tIns="18288" rIns="36576" anchor="t">
             <a:spAutoFit/>
           </a:bodyPr>
           <a:lstStyle/>
@@ -3921,6 +3948,7 @@
           <a:lstStyle/>
           <a:p>
             <a:pPr algn="ctr"/>
+            <a:endParaRPr/>
           </a:p>
         </p:txBody>
       </p:sp>
@@ -3966,6 +3994,7 @@
           <a:lstStyle/>
           <a:p>
             <a:pPr algn="ctr"/>
+            <a:endParaRPr/>
           </a:p>
         </p:txBody>
       </p:sp>
@@ -3986,7 +4015,7 @@
           <a:noFill/>
         </p:spPr>
         <p:txBody>
-          <a:bodyPr wrap="square" lIns="36576" rIns="36576" tIns="18288" anchor="t">
+          <a:bodyPr wrap="square" lIns="36576" tIns="18288" rIns="36576" anchor="t">
             <a:spAutoFit/>
           </a:bodyPr>
           <a:lstStyle/>
@@ -4149,6 +4178,7 @@
           <a:lstStyle/>
           <a:p>
             <a:pPr algn="ctr"/>
+            <a:endParaRPr/>
           </a:p>
         </p:txBody>
       </p:sp>
@@ -4194,6 +4224,7 @@
           <a:lstStyle/>
           <a:p>
             <a:pPr algn="ctr"/>
+            <a:endParaRPr/>
           </a:p>
         </p:txBody>
       </p:sp>
@@ -4214,7 +4245,7 @@
           <a:noFill/>
         </p:spPr>
         <p:txBody>
-          <a:bodyPr wrap="square" lIns="36576" rIns="36576" tIns="18288" anchor="t">
+          <a:bodyPr wrap="square" lIns="36576" tIns="18288" rIns="36576" anchor="t">
             <a:spAutoFit/>
           </a:bodyPr>
           <a:lstStyle/>
@@ -4352,7 +4383,7 @@
           <a:noFill/>
         </p:spPr>
         <p:txBody>
-          <a:bodyPr wrap="square" lIns="36576" rIns="36576" tIns="18288" anchor="t">
+          <a:bodyPr wrap="square" lIns="36576" tIns="18288" rIns="36576" anchor="t">
             <a:spAutoFit/>
           </a:bodyPr>
           <a:lstStyle/>
@@ -4375,11 +4406,18 @@
   <p:clrMapOvr>
     <a:masterClrMapping/>
   </p:clrMapOvr>
+  <p:timing>
+    <p:tnLst>
+      <p:par>
+        <p:cTn id="1" dur="indefinite" restart="never" nodeType="tmRoot"/>
+      </p:par>
+    </p:tnLst>
+  </p:timing>
 </p:sld>
 </file>
 
 <file path=ppt/slides/slide11.xml><?xml version="1.0" encoding="utf-8"?>
-<p:sld xmlns:a="http://schemas.openxmlformats.org/drawingml/2006/main" xmlns:p="http://schemas.openxmlformats.org/presentationml/2006/main" xmlns:r="http://schemas.openxmlformats.org/officeDocument/2006/relationships">
+<p:sld xmlns:a="http://schemas.openxmlformats.org/drawingml/2006/main" xmlns:r="http://schemas.openxmlformats.org/officeDocument/2006/relationships" xmlns:p="http://schemas.openxmlformats.org/presentationml/2006/main">
   <p:cSld>
     <p:bg>
       <p:bgPr>
@@ -4395,7 +4433,14 @@
         <p:cNvGrpSpPr/>
         <p:nvPr/>
       </p:nvGrpSpPr>
-      <p:grpSpPr/>
+      <p:grpSpPr>
+        <a:xfrm>
+          <a:off x="0" y="0"/>
+          <a:ext cx="0" cy="0"/>
+          <a:chOff x="0" y="0"/>
+          <a:chExt cx="0" cy="0"/>
+        </a:xfrm>
+      </p:grpSpPr>
       <p:sp>
         <p:nvSpPr>
           <p:cNvPr id="2" name="Rectangle 1"/>
@@ -4438,6 +4483,7 @@
           <a:lstStyle/>
           <a:p>
             <a:pPr algn="ctr"/>
+            <a:endParaRPr/>
           </a:p>
         </p:txBody>
       </p:sp>
@@ -4458,7 +4504,7 @@
           <a:noFill/>
         </p:spPr>
         <p:txBody>
-          <a:bodyPr wrap="square" lIns="36576" rIns="36576" tIns="18288" anchor="t">
+          <a:bodyPr wrap="square" lIns="36576" tIns="18288" rIns="36576" anchor="t">
             <a:spAutoFit/>
           </a:bodyPr>
           <a:lstStyle/>
@@ -4493,7 +4539,7 @@
           <a:noFill/>
         </p:spPr>
         <p:txBody>
-          <a:bodyPr wrap="square" lIns="36576" rIns="36576" tIns="18288" anchor="t">
+          <a:bodyPr wrap="square" lIns="36576" tIns="18288" rIns="36576" anchor="t">
             <a:spAutoFit/>
           </a:bodyPr>
           <a:lstStyle/>
@@ -4528,7 +4574,7 @@
           <a:noFill/>
         </p:spPr>
         <p:txBody>
-          <a:bodyPr wrap="square" lIns="36576" rIns="36576" tIns="18288" anchor="t">
+          <a:bodyPr wrap="square" lIns="36576" tIns="18288" rIns="36576" anchor="t">
             <a:spAutoFit/>
           </a:bodyPr>
           <a:lstStyle/>
@@ -4563,7 +4609,7 @@
           <a:noFill/>
         </p:spPr>
         <p:txBody>
-          <a:bodyPr wrap="square" lIns="36576" rIns="36576" tIns="18288" anchor="t">
+          <a:bodyPr wrap="square" lIns="36576" tIns="18288" rIns="36576" anchor="t">
             <a:spAutoFit/>
           </a:bodyPr>
           <a:lstStyle/>
@@ -4623,6 +4669,7 @@
           <a:lstStyle/>
           <a:p>
             <a:pPr algn="ctr"/>
+            <a:endParaRPr/>
           </a:p>
         </p:txBody>
       </p:sp>
@@ -4643,7 +4690,7 @@
           <a:noFill/>
         </p:spPr>
         <p:txBody>
-          <a:bodyPr wrap="square" lIns="36576" rIns="36576" tIns="18288" anchor="t">
+          <a:bodyPr wrap="square" lIns="36576" tIns="18288" rIns="36576" anchor="t">
             <a:spAutoFit/>
           </a:bodyPr>
           <a:lstStyle/>
@@ -4678,7 +4725,7 @@
           <a:noFill/>
         </p:spPr>
         <p:txBody>
-          <a:bodyPr wrap="square" lIns="36576" rIns="36576" tIns="18288" anchor="t">
+          <a:bodyPr wrap="square" lIns="36576" tIns="18288" rIns="36576" anchor="t">
             <a:spAutoFit/>
           </a:bodyPr>
           <a:lstStyle/>
@@ -4738,6 +4785,7 @@
           <a:lstStyle/>
           <a:p>
             <a:pPr algn="ctr"/>
+            <a:endParaRPr/>
           </a:p>
         </p:txBody>
       </p:sp>
@@ -4758,7 +4806,7 @@
           <a:noFill/>
         </p:spPr>
         <p:txBody>
-          <a:bodyPr wrap="square" lIns="36576" rIns="36576" tIns="18288" anchor="t">
+          <a:bodyPr wrap="square" lIns="36576" tIns="18288" rIns="36576" anchor="t">
             <a:spAutoFit/>
           </a:bodyPr>
           <a:lstStyle/>
@@ -4793,7 +4841,7 @@
           <a:noFill/>
         </p:spPr>
         <p:txBody>
-          <a:bodyPr wrap="square" lIns="36576" rIns="36576" tIns="18288" anchor="t">
+          <a:bodyPr wrap="square" lIns="36576" tIns="18288" rIns="36576" anchor="t">
             <a:spAutoFit/>
           </a:bodyPr>
           <a:lstStyle/>
@@ -4853,6 +4901,7 @@
           <a:lstStyle/>
           <a:p>
             <a:pPr algn="ctr"/>
+            <a:endParaRPr/>
           </a:p>
         </p:txBody>
       </p:sp>
@@ -4873,7 +4922,7 @@
           <a:noFill/>
         </p:spPr>
         <p:txBody>
-          <a:bodyPr wrap="square" lIns="36576" rIns="36576" tIns="18288" anchor="t">
+          <a:bodyPr wrap="square" lIns="36576" tIns="18288" rIns="36576" anchor="t">
             <a:spAutoFit/>
           </a:bodyPr>
           <a:lstStyle/>
@@ -4908,7 +4957,7 @@
           <a:noFill/>
         </p:spPr>
         <p:txBody>
-          <a:bodyPr wrap="square" lIns="36576" rIns="36576" tIns="18288" anchor="t">
+          <a:bodyPr wrap="square" lIns="36576" tIns="18288" rIns="36576" anchor="t">
             <a:spAutoFit/>
           </a:bodyPr>
           <a:lstStyle/>
@@ -4968,6 +5017,7 @@
           <a:lstStyle/>
           <a:p>
             <a:pPr algn="ctr"/>
+            <a:endParaRPr/>
           </a:p>
         </p:txBody>
       </p:sp>
@@ -4988,7 +5038,7 @@
           <a:noFill/>
         </p:spPr>
         <p:txBody>
-          <a:bodyPr wrap="square" lIns="36576" rIns="36576" tIns="18288" anchor="t">
+          <a:bodyPr wrap="square" lIns="36576" tIns="18288" rIns="36576" anchor="t">
             <a:spAutoFit/>
           </a:bodyPr>
           <a:lstStyle/>
@@ -5023,7 +5073,7 @@
           <a:noFill/>
         </p:spPr>
         <p:txBody>
-          <a:bodyPr wrap="square" lIns="36576" rIns="36576" tIns="18288" anchor="t">
+          <a:bodyPr wrap="square" lIns="36576" tIns="18288" rIns="36576" anchor="t">
             <a:spAutoFit/>
           </a:bodyPr>
           <a:lstStyle/>
@@ -5083,6 +5133,7 @@
           <a:lstStyle/>
           <a:p>
             <a:pPr algn="ctr"/>
+            <a:endParaRPr/>
           </a:p>
         </p:txBody>
       </p:sp>
@@ -5103,7 +5154,7 @@
           <a:noFill/>
         </p:spPr>
         <p:txBody>
-          <a:bodyPr wrap="square" lIns="36576" rIns="36576" tIns="18288" anchor="t">
+          <a:bodyPr wrap="square" lIns="36576" tIns="18288" rIns="36576" anchor="t">
             <a:spAutoFit/>
           </a:bodyPr>
           <a:lstStyle/>
@@ -5138,7 +5189,7 @@
           <a:noFill/>
         </p:spPr>
         <p:txBody>
-          <a:bodyPr wrap="square" lIns="36576" rIns="36576" tIns="18288" anchor="t">
+          <a:bodyPr wrap="square" lIns="36576" tIns="18288" rIns="36576" anchor="t">
             <a:spAutoFit/>
           </a:bodyPr>
           <a:lstStyle/>
@@ -5198,6 +5249,7 @@
           <a:lstStyle/>
           <a:p>
             <a:pPr algn="ctr"/>
+            <a:endParaRPr/>
           </a:p>
         </p:txBody>
       </p:sp>
@@ -5218,7 +5270,7 @@
           <a:noFill/>
         </p:spPr>
         <p:txBody>
-          <a:bodyPr wrap="square" lIns="36576" rIns="36576" tIns="18288" anchor="t">
+          <a:bodyPr wrap="square" lIns="36576" tIns="18288" rIns="36576" anchor="t">
             <a:spAutoFit/>
           </a:bodyPr>
           <a:lstStyle/>
@@ -5253,7 +5305,7 @@
           <a:noFill/>
         </p:spPr>
         <p:txBody>
-          <a:bodyPr wrap="square" lIns="36576" rIns="36576" tIns="18288" anchor="t">
+          <a:bodyPr wrap="square" lIns="36576" tIns="18288" rIns="36576" anchor="t">
             <a:spAutoFit/>
           </a:bodyPr>
           <a:lstStyle/>
@@ -5313,6 +5365,7 @@
           <a:lstStyle/>
           <a:p>
             <a:pPr algn="ctr"/>
+            <a:endParaRPr/>
           </a:p>
         </p:txBody>
       </p:sp>
@@ -5358,6 +5411,7 @@
           <a:lstStyle/>
           <a:p>
             <a:pPr algn="ctr"/>
+            <a:endParaRPr/>
           </a:p>
         </p:txBody>
       </p:sp>
@@ -5378,7 +5432,7 @@
           <a:noFill/>
         </p:spPr>
         <p:txBody>
-          <a:bodyPr wrap="square" lIns="36576" rIns="36576" tIns="18288" anchor="t">
+          <a:bodyPr wrap="square" lIns="36576" tIns="18288" rIns="36576" anchor="t">
             <a:spAutoFit/>
           </a:bodyPr>
           <a:lstStyle/>
@@ -5413,7 +5467,7 @@
           <a:noFill/>
         </p:spPr>
         <p:txBody>
-          <a:bodyPr wrap="square" lIns="36576" rIns="36576" tIns="18288" anchor="t">
+          <a:bodyPr wrap="square" lIns="36576" tIns="18288" rIns="36576" anchor="t">
             <a:spAutoFit/>
           </a:bodyPr>
           <a:lstStyle/>
@@ -5436,11 +5490,18 @@
   <p:clrMapOvr>
     <a:masterClrMapping/>
   </p:clrMapOvr>
+  <p:timing>
+    <p:tnLst>
+      <p:par>
+        <p:cTn id="1" dur="indefinite" restart="never" nodeType="tmRoot"/>
+      </p:par>
+    </p:tnLst>
+  </p:timing>
 </p:sld>
 </file>
 
 <file path=ppt/slides/slide12.xml><?xml version="1.0" encoding="utf-8"?>
-<p:sld xmlns:a="http://schemas.openxmlformats.org/drawingml/2006/main" xmlns:p="http://schemas.openxmlformats.org/presentationml/2006/main" xmlns:r="http://schemas.openxmlformats.org/officeDocument/2006/relationships">
+<p:sld xmlns:a="http://schemas.openxmlformats.org/drawingml/2006/main" xmlns:r="http://schemas.openxmlformats.org/officeDocument/2006/relationships" xmlns:p="http://schemas.openxmlformats.org/presentationml/2006/main">
   <p:cSld>
     <p:bg>
       <p:bgPr>
@@ -5456,7 +5517,14 @@
         <p:cNvGrpSpPr/>
         <p:nvPr/>
       </p:nvGrpSpPr>
-      <p:grpSpPr/>
+      <p:grpSpPr>
+        <a:xfrm>
+          <a:off x="0" y="0"/>
+          <a:ext cx="0" cy="0"/>
+          <a:chOff x="0" y="0"/>
+          <a:chExt cx="0" cy="0"/>
+        </a:xfrm>
+      </p:grpSpPr>
       <p:sp>
         <p:nvSpPr>
           <p:cNvPr id="2" name="Rectangle 1"/>
@@ -5499,6 +5567,7 @@
           <a:lstStyle/>
           <a:p>
             <a:pPr algn="ctr"/>
+            <a:endParaRPr/>
           </a:p>
         </p:txBody>
       </p:sp>
@@ -5519,7 +5588,7 @@
           <a:noFill/>
         </p:spPr>
         <p:txBody>
-          <a:bodyPr wrap="square" lIns="36576" rIns="36576" tIns="18288" anchor="t">
+          <a:bodyPr wrap="square" lIns="36576" tIns="18288" rIns="36576" anchor="t">
             <a:spAutoFit/>
           </a:bodyPr>
           <a:lstStyle/>
@@ -5554,7 +5623,7 @@
           <a:noFill/>
         </p:spPr>
         <p:txBody>
-          <a:bodyPr wrap="square" lIns="36576" rIns="36576" tIns="18288" anchor="t">
+          <a:bodyPr wrap="square" lIns="36576" tIns="18288" rIns="36576" anchor="t">
             <a:spAutoFit/>
           </a:bodyPr>
           <a:lstStyle/>
@@ -5589,7 +5658,7 @@
           <a:noFill/>
         </p:spPr>
         <p:txBody>
-          <a:bodyPr wrap="square" lIns="36576" rIns="36576" tIns="18288" anchor="t">
+          <a:bodyPr wrap="square" lIns="36576" tIns="18288" rIns="36576" anchor="t">
             <a:spAutoFit/>
           </a:bodyPr>
           <a:lstStyle/>
@@ -5624,14 +5693,14 @@
           <a:noFill/>
         </p:spPr>
         <p:txBody>
-          <a:bodyPr wrap="square" lIns="36576" rIns="36576" tIns="18288" anchor="t">
+          <a:bodyPr wrap="square" lIns="36576" tIns="18288" rIns="36576" anchor="t">
             <a:spAutoFit/>
           </a:bodyPr>
           <a:lstStyle/>
           <a:p>
             <a:pPr algn="l"/>
             <a:r>
-              <a:rPr sz="3000" b="1">
+              <a:rPr sz="3000" b="1" dirty="0">
                 <a:solidFill>
                   <a:srgbClr val="F4F7F8"/>
                 </a:solidFill>
@@ -5659,7 +5728,7 @@
           <a:noFill/>
         </p:spPr>
         <p:txBody>
-          <a:bodyPr wrap="square" lIns="36576" rIns="36576" tIns="18288" anchor="t">
+          <a:bodyPr wrap="square" lIns="36576" tIns="18288" rIns="36576" anchor="t">
             <a:spAutoFit/>
           </a:bodyPr>
           <a:lstStyle/>
@@ -5721,6 +5790,7 @@
           <a:lstStyle/>
           <a:p>
             <a:pPr algn="ctr"/>
+            <a:endParaRPr/>
           </a:p>
         </p:txBody>
       </p:sp>
@@ -5766,6 +5836,7 @@
           <a:lstStyle/>
           <a:p>
             <a:pPr algn="ctr"/>
+            <a:endParaRPr/>
           </a:p>
         </p:txBody>
       </p:sp>
@@ -5786,7 +5857,7 @@
           <a:noFill/>
         </p:spPr>
         <p:txBody>
-          <a:bodyPr wrap="square" lIns="36576" rIns="36576" tIns="18288" anchor="t">
+          <a:bodyPr wrap="square" lIns="36576" tIns="18288" rIns="36576" anchor="t">
             <a:spAutoFit/>
           </a:bodyPr>
           <a:lstStyle/>
@@ -5940,7 +6011,7 @@
           <a:noFill/>
         </p:spPr>
         <p:txBody>
-          <a:bodyPr wrap="square" lIns="36576" rIns="36576" tIns="18288" anchor="t">
+          <a:bodyPr wrap="square" lIns="36576" tIns="18288" rIns="36576" anchor="t">
             <a:spAutoFit/>
           </a:bodyPr>
           <a:lstStyle/>
@@ -5963,11 +6034,18 @@
   <p:clrMapOvr>
     <a:masterClrMapping/>
   </p:clrMapOvr>
+  <p:timing>
+    <p:tnLst>
+      <p:par>
+        <p:cTn id="1" dur="indefinite" restart="never" nodeType="tmRoot"/>
+      </p:par>
+    </p:tnLst>
+  </p:timing>
 </p:sld>
 </file>
 
 <file path=ppt/slides/slide2.xml><?xml version="1.0" encoding="utf-8"?>
-<p:sld xmlns:a="http://schemas.openxmlformats.org/drawingml/2006/main" xmlns:p="http://schemas.openxmlformats.org/presentationml/2006/main" xmlns:r="http://schemas.openxmlformats.org/officeDocument/2006/relationships">
+<p:sld xmlns:a="http://schemas.openxmlformats.org/drawingml/2006/main" xmlns:r="http://schemas.openxmlformats.org/officeDocument/2006/relationships" xmlns:p="http://schemas.openxmlformats.org/presentationml/2006/main">
   <p:cSld>
     <p:bg>
       <p:bgPr>
@@ -5983,7 +6061,14 @@
         <p:cNvGrpSpPr/>
         <p:nvPr/>
       </p:nvGrpSpPr>
-      <p:grpSpPr/>
+      <p:grpSpPr>
+        <a:xfrm>
+          <a:off x="0" y="0"/>
+          <a:ext cx="0" cy="0"/>
+          <a:chOff x="0" y="0"/>
+          <a:chExt cx="0" cy="0"/>
+        </a:xfrm>
+      </p:grpSpPr>
       <p:sp>
         <p:nvSpPr>
           <p:cNvPr id="2" name="Rectangle 1"/>
@@ -6026,6 +6111,7 @@
           <a:lstStyle/>
           <a:p>
             <a:pPr algn="ctr"/>
+            <a:endParaRPr/>
           </a:p>
         </p:txBody>
       </p:sp>
@@ -6046,7 +6132,7 @@
           <a:noFill/>
         </p:spPr>
         <p:txBody>
-          <a:bodyPr wrap="square" lIns="36576" rIns="36576" tIns="18288" anchor="t">
+          <a:bodyPr wrap="square" lIns="36576" tIns="18288" rIns="36576" anchor="t">
             <a:spAutoFit/>
           </a:bodyPr>
           <a:lstStyle/>
@@ -6081,7 +6167,7 @@
           <a:noFill/>
         </p:spPr>
         <p:txBody>
-          <a:bodyPr wrap="square" lIns="36576" rIns="36576" tIns="18288" anchor="t">
+          <a:bodyPr wrap="square" lIns="36576" tIns="18288" rIns="36576" anchor="t">
             <a:spAutoFit/>
           </a:bodyPr>
           <a:lstStyle/>
@@ -6116,7 +6202,7 @@
           <a:noFill/>
         </p:spPr>
         <p:txBody>
-          <a:bodyPr wrap="square" lIns="36576" rIns="36576" tIns="18288" anchor="t">
+          <a:bodyPr wrap="square" lIns="36576" tIns="18288" rIns="36576" anchor="t">
             <a:spAutoFit/>
           </a:bodyPr>
           <a:lstStyle/>
@@ -6151,7 +6237,7 @@
           <a:noFill/>
         </p:spPr>
         <p:txBody>
-          <a:bodyPr wrap="square" lIns="36576" rIns="36576" tIns="18288" anchor="t">
+          <a:bodyPr wrap="square" lIns="36576" tIns="18288" rIns="36576" anchor="t">
             <a:spAutoFit/>
           </a:bodyPr>
           <a:lstStyle/>
@@ -6211,6 +6297,7 @@
           <a:lstStyle/>
           <a:p>
             <a:pPr algn="ctr"/>
+            <a:endParaRPr/>
           </a:p>
         </p:txBody>
       </p:sp>
@@ -6256,6 +6343,7 @@
           <a:lstStyle/>
           <a:p>
             <a:pPr algn="ctr"/>
+            <a:endParaRPr/>
           </a:p>
         </p:txBody>
       </p:sp>
@@ -6276,7 +6364,7 @@
           <a:noFill/>
         </p:spPr>
         <p:txBody>
-          <a:bodyPr wrap="square" lIns="36576" rIns="36576" tIns="18288" anchor="t">
+          <a:bodyPr wrap="square" lIns="36576" tIns="18288" rIns="36576" anchor="t">
             <a:spAutoFit/>
           </a:bodyPr>
           <a:lstStyle/>
@@ -6407,6 +6495,7 @@
           <a:lstStyle/>
           <a:p>
             <a:pPr algn="ctr"/>
+            <a:endParaRPr/>
           </a:p>
         </p:txBody>
       </p:sp>
@@ -6452,6 +6541,7 @@
           <a:lstStyle/>
           <a:p>
             <a:pPr algn="ctr"/>
+            <a:endParaRPr/>
           </a:p>
         </p:txBody>
       </p:sp>
@@ -6472,7 +6562,7 @@
           <a:noFill/>
         </p:spPr>
         <p:txBody>
-          <a:bodyPr wrap="square" lIns="36576" rIns="36576" tIns="18288" anchor="t">
+          <a:bodyPr wrap="square" lIns="36576" tIns="18288" rIns="36576" anchor="t">
             <a:spAutoFit/>
           </a:bodyPr>
           <a:lstStyle/>
@@ -6603,6 +6693,7 @@
           <a:lstStyle/>
           <a:p>
             <a:pPr algn="ctr"/>
+            <a:endParaRPr/>
           </a:p>
         </p:txBody>
       </p:sp>
@@ -6648,6 +6739,7 @@
           <a:lstStyle/>
           <a:p>
             <a:pPr algn="ctr"/>
+            <a:endParaRPr/>
           </a:p>
         </p:txBody>
       </p:sp>
@@ -6668,7 +6760,7 @@
           <a:noFill/>
         </p:spPr>
         <p:txBody>
-          <a:bodyPr wrap="square" lIns="36576" rIns="36576" tIns="18288" anchor="t">
+          <a:bodyPr wrap="square" lIns="36576" tIns="18288" rIns="36576" anchor="t">
             <a:spAutoFit/>
           </a:bodyPr>
           <a:lstStyle/>
@@ -6762,11 +6854,18 @@
   <p:clrMapOvr>
     <a:masterClrMapping/>
   </p:clrMapOvr>
+  <p:timing>
+    <p:tnLst>
+      <p:par>
+        <p:cTn id="1" dur="indefinite" restart="never" nodeType="tmRoot"/>
+      </p:par>
+    </p:tnLst>
+  </p:timing>
 </p:sld>
 </file>
 
 <file path=ppt/slides/slide3.xml><?xml version="1.0" encoding="utf-8"?>
-<p:sld xmlns:a="http://schemas.openxmlformats.org/drawingml/2006/main" xmlns:p="http://schemas.openxmlformats.org/presentationml/2006/main" xmlns:r="http://schemas.openxmlformats.org/officeDocument/2006/relationships">
+<p:sld xmlns:a="http://schemas.openxmlformats.org/drawingml/2006/main" xmlns:r="http://schemas.openxmlformats.org/officeDocument/2006/relationships" xmlns:p="http://schemas.openxmlformats.org/presentationml/2006/main">
   <p:cSld>
     <p:bg>
       <p:bgPr>
@@ -6782,7 +6881,14 @@
         <p:cNvGrpSpPr/>
         <p:nvPr/>
       </p:nvGrpSpPr>
-      <p:grpSpPr/>
+      <p:grpSpPr>
+        <a:xfrm>
+          <a:off x="0" y="0"/>
+          <a:ext cx="0" cy="0"/>
+          <a:chOff x="0" y="0"/>
+          <a:chExt cx="0" cy="0"/>
+        </a:xfrm>
+      </p:grpSpPr>
       <p:sp>
         <p:nvSpPr>
           <p:cNvPr id="2" name="Rectangle 1"/>
@@ -6825,6 +6931,7 @@
           <a:lstStyle/>
           <a:p>
             <a:pPr algn="ctr"/>
+            <a:endParaRPr/>
           </a:p>
         </p:txBody>
       </p:sp>
@@ -6845,7 +6952,7 @@
           <a:noFill/>
         </p:spPr>
         <p:txBody>
-          <a:bodyPr wrap="square" lIns="36576" rIns="36576" tIns="18288" anchor="t">
+          <a:bodyPr wrap="square" lIns="36576" tIns="18288" rIns="36576" anchor="t">
             <a:spAutoFit/>
           </a:bodyPr>
           <a:lstStyle/>
@@ -6880,7 +6987,7 @@
           <a:noFill/>
         </p:spPr>
         <p:txBody>
-          <a:bodyPr wrap="square" lIns="36576" rIns="36576" tIns="18288" anchor="t">
+          <a:bodyPr wrap="square" lIns="36576" tIns="18288" rIns="36576" anchor="t">
             <a:spAutoFit/>
           </a:bodyPr>
           <a:lstStyle/>
@@ -6915,7 +7022,7 @@
           <a:noFill/>
         </p:spPr>
         <p:txBody>
-          <a:bodyPr wrap="square" lIns="36576" rIns="36576" tIns="18288" anchor="t">
+          <a:bodyPr wrap="square" lIns="36576" tIns="18288" rIns="36576" anchor="t">
             <a:spAutoFit/>
           </a:bodyPr>
           <a:lstStyle/>
@@ -6950,7 +7057,7 @@
           <a:noFill/>
         </p:spPr>
         <p:txBody>
-          <a:bodyPr wrap="square" lIns="36576" rIns="36576" tIns="18288" anchor="t">
+          <a:bodyPr wrap="square" lIns="36576" tIns="18288" rIns="36576" anchor="t">
             <a:spAutoFit/>
           </a:bodyPr>
           <a:lstStyle/>
@@ -7010,6 +7117,7 @@
           <a:lstStyle/>
           <a:p>
             <a:pPr algn="ctr"/>
+            <a:endParaRPr/>
           </a:p>
         </p:txBody>
       </p:sp>
@@ -7030,7 +7138,7 @@
           <a:noFill/>
         </p:spPr>
         <p:txBody>
-          <a:bodyPr wrap="square" lIns="36576" rIns="36576" tIns="18288" anchor="t">
+          <a:bodyPr wrap="square" lIns="36576" tIns="18288" rIns="36576" anchor="t">
             <a:spAutoFit/>
           </a:bodyPr>
           <a:lstStyle/>
@@ -7065,7 +7173,7 @@
           <a:noFill/>
         </p:spPr>
         <p:txBody>
-          <a:bodyPr wrap="square" lIns="36576" rIns="36576" tIns="18288" anchor="t">
+          <a:bodyPr wrap="square" lIns="36576" tIns="18288" rIns="36576" anchor="t">
             <a:spAutoFit/>
           </a:bodyPr>
           <a:lstStyle/>
@@ -7125,6 +7233,7 @@
           <a:lstStyle/>
           <a:p>
             <a:pPr algn="ctr"/>
+            <a:endParaRPr/>
           </a:p>
         </p:txBody>
       </p:sp>
@@ -7145,7 +7254,7 @@
           <a:noFill/>
         </p:spPr>
         <p:txBody>
-          <a:bodyPr wrap="square" lIns="36576" rIns="36576" tIns="18288" anchor="t">
+          <a:bodyPr wrap="square" lIns="36576" tIns="18288" rIns="36576" anchor="t">
             <a:spAutoFit/>
           </a:bodyPr>
           <a:lstStyle/>
@@ -7180,7 +7289,7 @@
           <a:noFill/>
         </p:spPr>
         <p:txBody>
-          <a:bodyPr wrap="square" lIns="36576" rIns="36576" tIns="18288" anchor="t">
+          <a:bodyPr wrap="square" lIns="36576" tIns="18288" rIns="36576" anchor="t">
             <a:spAutoFit/>
           </a:bodyPr>
           <a:lstStyle/>
@@ -7240,6 +7349,7 @@
           <a:lstStyle/>
           <a:p>
             <a:pPr algn="ctr"/>
+            <a:endParaRPr/>
           </a:p>
         </p:txBody>
       </p:sp>
@@ -7260,7 +7370,7 @@
           <a:noFill/>
         </p:spPr>
         <p:txBody>
-          <a:bodyPr wrap="square" lIns="36576" rIns="36576" tIns="18288" anchor="t">
+          <a:bodyPr wrap="square" lIns="36576" tIns="18288" rIns="36576" anchor="t">
             <a:spAutoFit/>
           </a:bodyPr>
           <a:lstStyle/>
@@ -7295,7 +7405,7 @@
           <a:noFill/>
         </p:spPr>
         <p:txBody>
-          <a:bodyPr wrap="square" lIns="36576" rIns="36576" tIns="18288" anchor="t">
+          <a:bodyPr wrap="square" lIns="36576" tIns="18288" rIns="36576" anchor="t">
             <a:spAutoFit/>
           </a:bodyPr>
           <a:lstStyle/>
@@ -7355,6 +7465,7 @@
           <a:lstStyle/>
           <a:p>
             <a:pPr algn="ctr"/>
+            <a:endParaRPr/>
           </a:p>
         </p:txBody>
       </p:sp>
@@ -7375,7 +7486,7 @@
           <a:noFill/>
         </p:spPr>
         <p:txBody>
-          <a:bodyPr wrap="square" lIns="36576" rIns="36576" tIns="18288" anchor="t">
+          <a:bodyPr wrap="square" lIns="36576" tIns="18288" rIns="36576" anchor="t">
             <a:spAutoFit/>
           </a:bodyPr>
           <a:lstStyle/>
@@ -7410,7 +7521,7 @@
           <a:noFill/>
         </p:spPr>
         <p:txBody>
-          <a:bodyPr wrap="square" lIns="36576" rIns="36576" tIns="18288" anchor="t">
+          <a:bodyPr wrap="square" lIns="36576" tIns="18288" rIns="36576" anchor="t">
             <a:spAutoFit/>
           </a:bodyPr>
           <a:lstStyle/>
@@ -7470,6 +7581,7 @@
           <a:lstStyle/>
           <a:p>
             <a:pPr algn="ctr"/>
+            <a:endParaRPr/>
           </a:p>
         </p:txBody>
       </p:sp>
@@ -7490,7 +7602,7 @@
           <a:noFill/>
         </p:spPr>
         <p:txBody>
-          <a:bodyPr wrap="square" lIns="36576" rIns="36576" tIns="18288" anchor="t">
+          <a:bodyPr wrap="square" lIns="36576" tIns="18288" rIns="36576" anchor="t">
             <a:spAutoFit/>
           </a:bodyPr>
           <a:lstStyle/>
@@ -7525,7 +7637,7 @@
           <a:noFill/>
         </p:spPr>
         <p:txBody>
-          <a:bodyPr wrap="square" lIns="36576" rIns="36576" tIns="18288" anchor="t">
+          <a:bodyPr wrap="square" lIns="36576" tIns="18288" rIns="36576" anchor="t">
             <a:spAutoFit/>
           </a:bodyPr>
           <a:lstStyle/>
@@ -7585,6 +7697,7 @@
           <a:lstStyle/>
           <a:p>
             <a:pPr algn="ctr"/>
+            <a:endParaRPr/>
           </a:p>
         </p:txBody>
       </p:sp>
@@ -7605,7 +7718,7 @@
           <a:noFill/>
         </p:spPr>
         <p:txBody>
-          <a:bodyPr wrap="square" lIns="36576" rIns="36576" tIns="18288" anchor="t">
+          <a:bodyPr wrap="square" lIns="36576" tIns="18288" rIns="36576" anchor="t">
             <a:spAutoFit/>
           </a:bodyPr>
           <a:lstStyle/>
@@ -7665,6 +7778,7 @@
           <a:lstStyle/>
           <a:p>
             <a:pPr algn="ctr"/>
+            <a:endParaRPr/>
           </a:p>
         </p:txBody>
       </p:sp>
@@ -7710,6 +7824,7 @@
           <a:lstStyle/>
           <a:p>
             <a:pPr algn="ctr"/>
+            <a:endParaRPr/>
           </a:p>
         </p:txBody>
       </p:sp>
@@ -7730,7 +7845,7 @@
           <a:noFill/>
         </p:spPr>
         <p:txBody>
-          <a:bodyPr wrap="square" lIns="36576" rIns="36576" tIns="18288" anchor="t">
+          <a:bodyPr wrap="square" lIns="36576" tIns="18288" rIns="36576" anchor="t">
             <a:spAutoFit/>
           </a:bodyPr>
           <a:lstStyle/>
@@ -7757,22 +7872,22 @@
         <p:spPr>
           <a:xfrm>
             <a:off x="960120" y="4507992"/>
-            <a:ext cx="3017520" cy="576072"/>
-          </a:xfrm>
-          <a:prstGeom prst="rect">
-            <a:avLst/>
-          </a:prstGeom>
-          <a:noFill/>
-        </p:spPr>
-        <p:txBody>
-          <a:bodyPr wrap="square" lIns="36576" rIns="36576" tIns="18288" anchor="t">
+            <a:ext cx="3017520" cy="433965"/>
+          </a:xfrm>
+          <a:prstGeom prst="rect">
+            <a:avLst/>
+          </a:prstGeom>
+          <a:noFill/>
+        </p:spPr>
+        <p:txBody>
+          <a:bodyPr wrap="square" lIns="36576" tIns="18288" rIns="36576" anchor="t">
             <a:spAutoFit/>
           </a:bodyPr>
           <a:lstStyle/>
           <a:p>
             <a:pPr algn="l"/>
             <a:r>
-              <a:rPr sz="1400" b="0">
+              <a:rPr sz="1200" b="0" dirty="0">
                 <a:solidFill>
                   <a:srgbClr val="AABCC6"/>
                 </a:solidFill>
@@ -7825,6 +7940,7 @@
           <a:lstStyle/>
           <a:p>
             <a:pPr algn="ctr"/>
+            <a:endParaRPr/>
           </a:p>
         </p:txBody>
       </p:sp>
@@ -7870,6 +7986,7 @@
           <a:lstStyle/>
           <a:p>
             <a:pPr algn="ctr"/>
+            <a:endParaRPr/>
           </a:p>
         </p:txBody>
       </p:sp>
@@ -7890,7 +8007,7 @@
           <a:noFill/>
         </p:spPr>
         <p:txBody>
-          <a:bodyPr wrap="square" lIns="36576" rIns="36576" tIns="18288" anchor="t">
+          <a:bodyPr wrap="square" lIns="36576" tIns="18288" rIns="36576" anchor="t">
             <a:spAutoFit/>
           </a:bodyPr>
           <a:lstStyle/>
@@ -7917,22 +8034,22 @@
         <p:spPr>
           <a:xfrm>
             <a:off x="4617720" y="4507992"/>
-            <a:ext cx="3017520" cy="576072"/>
-          </a:xfrm>
-          <a:prstGeom prst="rect">
-            <a:avLst/>
-          </a:prstGeom>
-          <a:noFill/>
-        </p:spPr>
-        <p:txBody>
-          <a:bodyPr wrap="square" lIns="36576" rIns="36576" tIns="18288" anchor="t">
+            <a:ext cx="3017520" cy="433965"/>
+          </a:xfrm>
+          <a:prstGeom prst="rect">
+            <a:avLst/>
+          </a:prstGeom>
+          <a:noFill/>
+        </p:spPr>
+        <p:txBody>
+          <a:bodyPr wrap="square" lIns="36576" tIns="18288" rIns="36576" anchor="t">
             <a:spAutoFit/>
           </a:bodyPr>
           <a:lstStyle/>
           <a:p>
             <a:pPr algn="l"/>
             <a:r>
-              <a:rPr sz="1400" b="0">
+              <a:rPr sz="1200" b="0" dirty="0">
                 <a:solidFill>
                   <a:srgbClr val="AABCC6"/>
                 </a:solidFill>
@@ -7985,6 +8102,7 @@
           <a:lstStyle/>
           <a:p>
             <a:pPr algn="ctr"/>
+            <a:endParaRPr/>
           </a:p>
         </p:txBody>
       </p:sp>
@@ -8030,6 +8148,7 @@
           <a:lstStyle/>
           <a:p>
             <a:pPr algn="ctr"/>
+            <a:endParaRPr/>
           </a:p>
         </p:txBody>
       </p:sp>
@@ -8050,7 +8169,7 @@
           <a:noFill/>
         </p:spPr>
         <p:txBody>
-          <a:bodyPr wrap="square" lIns="36576" rIns="36576" tIns="18288" anchor="t">
+          <a:bodyPr wrap="square" lIns="36576" tIns="18288" rIns="36576" anchor="t">
             <a:spAutoFit/>
           </a:bodyPr>
           <a:lstStyle/>
@@ -8077,22 +8196,22 @@
         <p:spPr>
           <a:xfrm>
             <a:off x="8275320" y="4507992"/>
-            <a:ext cx="3017520" cy="576072"/>
-          </a:xfrm>
-          <a:prstGeom prst="rect">
-            <a:avLst/>
-          </a:prstGeom>
-          <a:noFill/>
-        </p:spPr>
-        <p:txBody>
-          <a:bodyPr wrap="square" lIns="36576" rIns="36576" tIns="18288" anchor="t">
+            <a:ext cx="3017520" cy="433965"/>
+          </a:xfrm>
+          <a:prstGeom prst="rect">
+            <a:avLst/>
+          </a:prstGeom>
+          <a:noFill/>
+        </p:spPr>
+        <p:txBody>
+          <a:bodyPr wrap="square" lIns="36576" tIns="18288" rIns="36576" anchor="t">
             <a:spAutoFit/>
           </a:bodyPr>
           <a:lstStyle/>
           <a:p>
             <a:pPr algn="l"/>
             <a:r>
-              <a:rPr sz="1400" b="0">
+              <a:rPr sz="1200" b="0" dirty="0">
                 <a:solidFill>
                   <a:srgbClr val="AABCC6"/>
                 </a:solidFill>
@@ -8108,11 +8227,18 @@
   <p:clrMapOvr>
     <a:masterClrMapping/>
   </p:clrMapOvr>
+  <p:timing>
+    <p:tnLst>
+      <p:par>
+        <p:cTn id="1" dur="indefinite" restart="never" nodeType="tmRoot"/>
+      </p:par>
+    </p:tnLst>
+  </p:timing>
 </p:sld>
 </file>
 
 <file path=ppt/slides/slide4.xml><?xml version="1.0" encoding="utf-8"?>
-<p:sld xmlns:a="http://schemas.openxmlformats.org/drawingml/2006/main" xmlns:p="http://schemas.openxmlformats.org/presentationml/2006/main" xmlns:r="http://schemas.openxmlformats.org/officeDocument/2006/relationships">
+<p:sld xmlns:a="http://schemas.openxmlformats.org/drawingml/2006/main" xmlns:r="http://schemas.openxmlformats.org/officeDocument/2006/relationships" xmlns:p="http://schemas.openxmlformats.org/presentationml/2006/main">
   <p:cSld>
     <p:bg>
       <p:bgPr>
@@ -8128,7 +8254,14 @@
         <p:cNvGrpSpPr/>
         <p:nvPr/>
       </p:nvGrpSpPr>
-      <p:grpSpPr/>
+      <p:grpSpPr>
+        <a:xfrm>
+          <a:off x="0" y="0"/>
+          <a:ext cx="0" cy="0"/>
+          <a:chOff x="0" y="0"/>
+          <a:chExt cx="0" cy="0"/>
+        </a:xfrm>
+      </p:grpSpPr>
       <p:sp>
         <p:nvSpPr>
           <p:cNvPr id="2" name="Rectangle 1"/>
@@ -8171,6 +8304,7 @@
           <a:lstStyle/>
           <a:p>
             <a:pPr algn="ctr"/>
+            <a:endParaRPr/>
           </a:p>
         </p:txBody>
       </p:sp>
@@ -8191,7 +8325,7 @@
           <a:noFill/>
         </p:spPr>
         <p:txBody>
-          <a:bodyPr wrap="square" lIns="36576" rIns="36576" tIns="18288" anchor="t">
+          <a:bodyPr wrap="square" lIns="36576" tIns="18288" rIns="36576" anchor="t">
             <a:spAutoFit/>
           </a:bodyPr>
           <a:lstStyle/>
@@ -8226,7 +8360,7 @@
           <a:noFill/>
         </p:spPr>
         <p:txBody>
-          <a:bodyPr wrap="square" lIns="36576" rIns="36576" tIns="18288" anchor="t">
+          <a:bodyPr wrap="square" lIns="36576" tIns="18288" rIns="36576" anchor="t">
             <a:spAutoFit/>
           </a:bodyPr>
           <a:lstStyle/>
@@ -8261,7 +8395,7 @@
           <a:noFill/>
         </p:spPr>
         <p:txBody>
-          <a:bodyPr wrap="square" lIns="36576" rIns="36576" tIns="18288" anchor="t">
+          <a:bodyPr wrap="square" lIns="36576" tIns="18288" rIns="36576" anchor="t">
             <a:spAutoFit/>
           </a:bodyPr>
           <a:lstStyle/>
@@ -8296,7 +8430,7 @@
           <a:noFill/>
         </p:spPr>
         <p:txBody>
-          <a:bodyPr wrap="square" lIns="36576" rIns="36576" tIns="18288" anchor="t">
+          <a:bodyPr wrap="square" lIns="36576" tIns="18288" rIns="36576" anchor="t">
             <a:spAutoFit/>
           </a:bodyPr>
           <a:lstStyle/>
@@ -8356,6 +8490,7 @@
           <a:lstStyle/>
           <a:p>
             <a:pPr algn="ctr"/>
+            <a:endParaRPr/>
           </a:p>
         </p:txBody>
       </p:sp>
@@ -8376,7 +8511,7 @@
           <a:noFill/>
         </p:spPr>
         <p:txBody>
-          <a:bodyPr wrap="square" lIns="36576" rIns="36576" tIns="18288" anchor="t">
+          <a:bodyPr wrap="square" lIns="36576" tIns="18288" rIns="36576" anchor="t">
             <a:spAutoFit/>
           </a:bodyPr>
           <a:lstStyle/>
@@ -8411,7 +8546,7 @@
           <a:noFill/>
         </p:spPr>
         <p:txBody>
-          <a:bodyPr wrap="square" lIns="36576" rIns="36576" tIns="18288" anchor="t">
+          <a:bodyPr wrap="square" lIns="36576" tIns="18288" rIns="36576" anchor="t">
             <a:spAutoFit/>
           </a:bodyPr>
           <a:lstStyle/>
@@ -8471,6 +8606,7 @@
           <a:lstStyle/>
           <a:p>
             <a:pPr algn="ctr"/>
+            <a:endParaRPr/>
           </a:p>
         </p:txBody>
       </p:sp>
@@ -8491,7 +8627,7 @@
           <a:noFill/>
         </p:spPr>
         <p:txBody>
-          <a:bodyPr wrap="square" lIns="36576" rIns="36576" tIns="18288" anchor="t">
+          <a:bodyPr wrap="square" lIns="36576" tIns="18288" rIns="36576" anchor="t">
             <a:spAutoFit/>
           </a:bodyPr>
           <a:lstStyle/>
@@ -8526,7 +8662,7 @@
           <a:noFill/>
         </p:spPr>
         <p:txBody>
-          <a:bodyPr wrap="square" lIns="36576" rIns="36576" tIns="18288" anchor="t">
+          <a:bodyPr wrap="square" lIns="36576" tIns="18288" rIns="36576" anchor="t">
             <a:spAutoFit/>
           </a:bodyPr>
           <a:lstStyle/>
@@ -8586,6 +8722,7 @@
           <a:lstStyle/>
           <a:p>
             <a:pPr algn="ctr"/>
+            <a:endParaRPr/>
           </a:p>
         </p:txBody>
       </p:sp>
@@ -8606,7 +8743,7 @@
           <a:noFill/>
         </p:spPr>
         <p:txBody>
-          <a:bodyPr wrap="square" lIns="36576" rIns="36576" tIns="18288" anchor="t">
+          <a:bodyPr wrap="square" lIns="36576" tIns="18288" rIns="36576" anchor="t">
             <a:spAutoFit/>
           </a:bodyPr>
           <a:lstStyle/>
@@ -8641,7 +8778,7 @@
           <a:noFill/>
         </p:spPr>
         <p:txBody>
-          <a:bodyPr wrap="square" lIns="36576" rIns="36576" tIns="18288" anchor="t">
+          <a:bodyPr wrap="square" lIns="36576" tIns="18288" rIns="36576" anchor="t">
             <a:spAutoFit/>
           </a:bodyPr>
           <a:lstStyle/>
@@ -8701,6 +8838,7 @@
           <a:lstStyle/>
           <a:p>
             <a:pPr algn="ctr"/>
+            <a:endParaRPr/>
           </a:p>
         </p:txBody>
       </p:sp>
@@ -8721,7 +8859,7 @@
           <a:noFill/>
         </p:spPr>
         <p:txBody>
-          <a:bodyPr wrap="square" lIns="36576" rIns="36576" tIns="18288" anchor="t">
+          <a:bodyPr wrap="square" lIns="36576" tIns="18288" rIns="36576" anchor="t">
             <a:spAutoFit/>
           </a:bodyPr>
           <a:lstStyle/>
@@ -8756,7 +8894,7 @@
           <a:noFill/>
         </p:spPr>
         <p:txBody>
-          <a:bodyPr wrap="square" lIns="36576" rIns="36576" tIns="18288" anchor="t">
+          <a:bodyPr wrap="square" lIns="36576" tIns="18288" rIns="36576" anchor="t">
             <a:spAutoFit/>
           </a:bodyPr>
           <a:lstStyle/>
@@ -8816,6 +8954,7 @@
           <a:lstStyle/>
           <a:p>
             <a:pPr algn="ctr"/>
+            <a:endParaRPr/>
           </a:p>
         </p:txBody>
       </p:sp>
@@ -8836,7 +8975,7 @@
           <a:noFill/>
         </p:spPr>
         <p:txBody>
-          <a:bodyPr wrap="square" lIns="36576" rIns="36576" tIns="18288" anchor="t">
+          <a:bodyPr wrap="square" lIns="36576" tIns="18288" rIns="36576" anchor="t">
             <a:spAutoFit/>
           </a:bodyPr>
           <a:lstStyle/>
@@ -8871,7 +9010,7 @@
           <a:noFill/>
         </p:spPr>
         <p:txBody>
-          <a:bodyPr wrap="square" lIns="36576" rIns="36576" tIns="18288" anchor="t">
+          <a:bodyPr wrap="square" lIns="36576" tIns="18288" rIns="36576" anchor="t">
             <a:spAutoFit/>
           </a:bodyPr>
           <a:lstStyle/>
@@ -8931,6 +9070,7 @@
           <a:lstStyle/>
           <a:p>
             <a:pPr algn="ctr"/>
+            <a:endParaRPr/>
           </a:p>
         </p:txBody>
       </p:sp>
@@ -8951,7 +9091,7 @@
           <a:noFill/>
         </p:spPr>
         <p:txBody>
-          <a:bodyPr wrap="square" lIns="36576" rIns="36576" tIns="18288" anchor="t">
+          <a:bodyPr wrap="square" lIns="36576" tIns="18288" rIns="36576" anchor="t">
             <a:spAutoFit/>
           </a:bodyPr>
           <a:lstStyle/>
@@ -8986,7 +9126,7 @@
           <a:noFill/>
         </p:spPr>
         <p:txBody>
-          <a:bodyPr wrap="square" lIns="36576" rIns="36576" tIns="18288" anchor="t">
+          <a:bodyPr wrap="square" lIns="36576" tIns="18288" rIns="36576" anchor="t">
             <a:spAutoFit/>
           </a:bodyPr>
           <a:lstStyle/>
@@ -9021,7 +9161,7 @@
           <a:noFill/>
         </p:spPr>
         <p:txBody>
-          <a:bodyPr wrap="square" lIns="36576" rIns="36576" tIns="18288" anchor="t">
+          <a:bodyPr wrap="square" lIns="36576" tIns="18288" rIns="36576" anchor="t">
             <a:spAutoFit/>
           </a:bodyPr>
           <a:lstStyle/>
@@ -9081,6 +9221,7 @@
           <a:lstStyle/>
           <a:p>
             <a:pPr algn="ctr"/>
+            <a:endParaRPr/>
           </a:p>
         </p:txBody>
       </p:sp>
@@ -9126,6 +9267,7 @@
           <a:lstStyle/>
           <a:p>
             <a:pPr algn="ctr"/>
+            <a:endParaRPr/>
           </a:p>
         </p:txBody>
       </p:sp>
@@ -9146,7 +9288,7 @@
           <a:noFill/>
         </p:spPr>
         <p:txBody>
-          <a:bodyPr wrap="square" lIns="36576" rIns="36576" tIns="18288" anchor="t">
+          <a:bodyPr wrap="square" lIns="36576" tIns="18288" rIns="36576" anchor="t">
             <a:spAutoFit/>
           </a:bodyPr>
           <a:lstStyle/>
@@ -9173,7 +9315,7 @@
         <p:spPr>
           <a:xfrm>
             <a:off x="1005840" y="4507992"/>
-            <a:ext cx="4572000" cy="804672"/>
+            <a:ext cx="4572000" cy="877163"/>
           </a:xfrm>
           <a:prstGeom prst="rect">
             <a:avLst/>
@@ -9198,6 +9340,7 @@
               </a:defRPr>
             </a:pPr>
             <a:r>
+              <a:rPr sz="1200" dirty="0"/>
               <a:t>•  Extract structure from unstructured text</a:t>
             </a:r>
           </a:p>
@@ -9214,6 +9357,7 @@
               </a:defRPr>
             </a:pPr>
             <a:r>
+              <a:rPr sz="1200" dirty="0"/>
               <a:t>•  Identify stated risk factors</a:t>
             </a:r>
           </a:p>
@@ -9230,6 +9374,7 @@
               </a:defRPr>
             </a:pPr>
             <a:r>
+              <a:rPr sz="1200" dirty="0"/>
               <a:t>•  Attempt semantic policy retrieval when configured</a:t>
             </a:r>
           </a:p>
@@ -9277,6 +9422,7 @@
           <a:lstStyle/>
           <a:p>
             <a:pPr algn="ctr"/>
+            <a:endParaRPr sz="1600"/>
           </a:p>
         </p:txBody>
       </p:sp>
@@ -9322,6 +9468,7 @@
           <a:lstStyle/>
           <a:p>
             <a:pPr algn="ctr"/>
+            <a:endParaRPr/>
           </a:p>
         </p:txBody>
       </p:sp>
@@ -9342,7 +9489,7 @@
           <a:noFill/>
         </p:spPr>
         <p:txBody>
-          <a:bodyPr wrap="square" lIns="36576" rIns="36576" tIns="18288" anchor="t">
+          <a:bodyPr wrap="square" lIns="36576" tIns="18288" rIns="36576" anchor="t">
             <a:spAutoFit/>
           </a:bodyPr>
           <a:lstStyle/>
@@ -9369,7 +9516,7 @@
         <p:spPr>
           <a:xfrm>
             <a:off x="6629400" y="4507992"/>
-            <a:ext cx="4572000" cy="804672"/>
+            <a:ext cx="4572000" cy="877163"/>
           </a:xfrm>
           <a:prstGeom prst="rect">
             <a:avLst/>
@@ -9394,6 +9541,7 @@
               </a:defRPr>
             </a:pPr>
             <a:r>
+              <a:rPr sz="1200" dirty="0"/>
               <a:t>•  Validate schemas</a:t>
             </a:r>
           </a:p>
@@ -9410,6 +9558,7 @@
               </a:defRPr>
             </a:pPr>
             <a:r>
+              <a:rPr sz="1200" dirty="0"/>
               <a:t>•  Calculate scores and thresholds</a:t>
             </a:r>
           </a:p>
@@ -9426,6 +9575,7 @@
               </a:defRPr>
             </a:pPr>
             <a:r>
+              <a:rPr sz="1200" dirty="0"/>
               <a:t>•  Persist workflow events; policy lookup falls back to rules</a:t>
             </a:r>
           </a:p>
@@ -9436,11 +9586,18 @@
   <p:clrMapOvr>
     <a:masterClrMapping/>
   </p:clrMapOvr>
+  <p:timing>
+    <p:tnLst>
+      <p:par>
+        <p:cTn id="1" dur="indefinite" restart="never" nodeType="tmRoot"/>
+      </p:par>
+    </p:tnLst>
+  </p:timing>
 </p:sld>
 </file>
 
 <file path=ppt/slides/slide5.xml><?xml version="1.0" encoding="utf-8"?>
-<p:sld xmlns:a="http://schemas.openxmlformats.org/drawingml/2006/main" xmlns:p="http://schemas.openxmlformats.org/presentationml/2006/main" xmlns:r="http://schemas.openxmlformats.org/officeDocument/2006/relationships">
+<p:sld xmlns:a="http://schemas.openxmlformats.org/drawingml/2006/main" xmlns:r="http://schemas.openxmlformats.org/officeDocument/2006/relationships" xmlns:p="http://schemas.openxmlformats.org/presentationml/2006/main">
   <p:cSld>
     <p:bg>
       <p:bgPr>
@@ -9456,7 +9613,14 @@
         <p:cNvGrpSpPr/>
         <p:nvPr/>
       </p:nvGrpSpPr>
-      <p:grpSpPr/>
+      <p:grpSpPr>
+        <a:xfrm>
+          <a:off x="0" y="0"/>
+          <a:ext cx="0" cy="0"/>
+          <a:chOff x="0" y="0"/>
+          <a:chExt cx="0" cy="0"/>
+        </a:xfrm>
+      </p:grpSpPr>
       <p:sp>
         <p:nvSpPr>
           <p:cNvPr id="2" name="Rectangle 1"/>
@@ -9499,6 +9663,7 @@
           <a:lstStyle/>
           <a:p>
             <a:pPr algn="ctr"/>
+            <a:endParaRPr/>
           </a:p>
         </p:txBody>
       </p:sp>
@@ -9519,7 +9684,7 @@
           <a:noFill/>
         </p:spPr>
         <p:txBody>
-          <a:bodyPr wrap="square" lIns="36576" rIns="36576" tIns="18288" anchor="t">
+          <a:bodyPr wrap="square" lIns="36576" tIns="18288" rIns="36576" anchor="t">
             <a:spAutoFit/>
           </a:bodyPr>
           <a:lstStyle/>
@@ -9554,7 +9719,7 @@
           <a:noFill/>
         </p:spPr>
         <p:txBody>
-          <a:bodyPr wrap="square" lIns="36576" rIns="36576" tIns="18288" anchor="t">
+          <a:bodyPr wrap="square" lIns="36576" tIns="18288" rIns="36576" anchor="t">
             <a:spAutoFit/>
           </a:bodyPr>
           <a:lstStyle/>
@@ -9589,7 +9754,7 @@
           <a:noFill/>
         </p:spPr>
         <p:txBody>
-          <a:bodyPr wrap="square" lIns="36576" rIns="36576" tIns="18288" anchor="t">
+          <a:bodyPr wrap="square" lIns="36576" tIns="18288" rIns="36576" anchor="t">
             <a:spAutoFit/>
           </a:bodyPr>
           <a:lstStyle/>
@@ -9624,7 +9789,7 @@
           <a:noFill/>
         </p:spPr>
         <p:txBody>
-          <a:bodyPr wrap="square" lIns="36576" rIns="36576" tIns="18288" anchor="t">
+          <a:bodyPr wrap="square" lIns="36576" tIns="18288" rIns="36576" anchor="t">
             <a:spAutoFit/>
           </a:bodyPr>
           <a:lstStyle/>
@@ -9684,6 +9849,7 @@
           <a:lstStyle/>
           <a:p>
             <a:pPr algn="ctr"/>
+            <a:endParaRPr/>
           </a:p>
         </p:txBody>
       </p:sp>
@@ -9729,6 +9895,7 @@
           <a:lstStyle/>
           <a:p>
             <a:pPr algn="ctr"/>
+            <a:endParaRPr/>
           </a:p>
         </p:txBody>
       </p:sp>
@@ -9749,7 +9916,7 @@
           <a:noFill/>
         </p:spPr>
         <p:txBody>
-          <a:bodyPr wrap="square" lIns="36576" rIns="36576" tIns="18288" anchor="t">
+          <a:bodyPr wrap="square" lIns="36576" tIns="18288" rIns="36576" anchor="t">
             <a:spAutoFit/>
           </a:bodyPr>
           <a:lstStyle/>
@@ -9880,6 +10047,7 @@
           <a:lstStyle/>
           <a:p>
             <a:pPr algn="ctr"/>
+            <a:endParaRPr/>
           </a:p>
         </p:txBody>
       </p:sp>
@@ -9925,6 +10093,7 @@
           <a:lstStyle/>
           <a:p>
             <a:pPr algn="ctr"/>
+            <a:endParaRPr/>
           </a:p>
         </p:txBody>
       </p:sp>
@@ -9945,7 +10114,7 @@
           <a:noFill/>
         </p:spPr>
         <p:txBody>
-          <a:bodyPr wrap="square" lIns="36576" rIns="36576" tIns="18288" anchor="t">
+          <a:bodyPr wrap="square" lIns="36576" tIns="18288" rIns="36576" anchor="t">
             <a:spAutoFit/>
           </a:bodyPr>
           <a:lstStyle/>
@@ -10076,6 +10245,7 @@
           <a:lstStyle/>
           <a:p>
             <a:pPr algn="ctr"/>
+            <a:endParaRPr/>
           </a:p>
         </p:txBody>
       </p:sp>
@@ -10121,6 +10291,7 @@
           <a:lstStyle/>
           <a:p>
             <a:pPr algn="ctr"/>
+            <a:endParaRPr/>
           </a:p>
         </p:txBody>
       </p:sp>
@@ -10141,7 +10312,7 @@
           <a:noFill/>
         </p:spPr>
         <p:txBody>
-          <a:bodyPr wrap="square" lIns="36576" rIns="36576" tIns="18288" anchor="t">
+          <a:bodyPr wrap="square" lIns="36576" tIns="18288" rIns="36576" anchor="t">
             <a:spAutoFit/>
           </a:bodyPr>
           <a:lstStyle/>
@@ -10235,11 +10406,18 @@
   <p:clrMapOvr>
     <a:masterClrMapping/>
   </p:clrMapOvr>
+  <p:timing>
+    <p:tnLst>
+      <p:par>
+        <p:cTn id="1" dur="indefinite" restart="never" nodeType="tmRoot"/>
+      </p:par>
+    </p:tnLst>
+  </p:timing>
 </p:sld>
 </file>
 
 <file path=ppt/slides/slide6.xml><?xml version="1.0" encoding="utf-8"?>
-<p:sld xmlns:a="http://schemas.openxmlformats.org/drawingml/2006/main" xmlns:p="http://schemas.openxmlformats.org/presentationml/2006/main" xmlns:r="http://schemas.openxmlformats.org/officeDocument/2006/relationships">
+<p:sld xmlns:a="http://schemas.openxmlformats.org/drawingml/2006/main" xmlns:r="http://schemas.openxmlformats.org/officeDocument/2006/relationships" xmlns:p="http://schemas.openxmlformats.org/presentationml/2006/main">
   <p:cSld>
     <p:bg>
       <p:bgPr>
@@ -10255,7 +10433,14 @@
         <p:cNvGrpSpPr/>
         <p:nvPr/>
       </p:nvGrpSpPr>
-      <p:grpSpPr/>
+      <p:grpSpPr>
+        <a:xfrm>
+          <a:off x="0" y="0"/>
+          <a:ext cx="0" cy="0"/>
+          <a:chOff x="0" y="0"/>
+          <a:chExt cx="0" cy="0"/>
+        </a:xfrm>
+      </p:grpSpPr>
       <p:sp>
         <p:nvSpPr>
           <p:cNvPr id="2" name="Rectangle 1"/>
@@ -10298,6 +10483,7 @@
           <a:lstStyle/>
           <a:p>
             <a:pPr algn="ctr"/>
+            <a:endParaRPr/>
           </a:p>
         </p:txBody>
       </p:sp>
@@ -10318,7 +10504,7 @@
           <a:noFill/>
         </p:spPr>
         <p:txBody>
-          <a:bodyPr wrap="square" lIns="36576" rIns="36576" tIns="18288" anchor="t">
+          <a:bodyPr wrap="square" lIns="36576" tIns="18288" rIns="36576" anchor="t">
             <a:spAutoFit/>
           </a:bodyPr>
           <a:lstStyle/>
@@ -10353,7 +10539,7 @@
           <a:noFill/>
         </p:spPr>
         <p:txBody>
-          <a:bodyPr wrap="square" lIns="36576" rIns="36576" tIns="18288" anchor="t">
+          <a:bodyPr wrap="square" lIns="36576" tIns="18288" rIns="36576" anchor="t">
             <a:spAutoFit/>
           </a:bodyPr>
           <a:lstStyle/>
@@ -10388,7 +10574,7 @@
           <a:noFill/>
         </p:spPr>
         <p:txBody>
-          <a:bodyPr wrap="square" lIns="36576" rIns="36576" tIns="18288" anchor="t">
+          <a:bodyPr wrap="square" lIns="36576" tIns="18288" rIns="36576" anchor="t">
             <a:spAutoFit/>
           </a:bodyPr>
           <a:lstStyle/>
@@ -10423,7 +10609,7 @@
           <a:noFill/>
         </p:spPr>
         <p:txBody>
-          <a:bodyPr wrap="square" lIns="36576" rIns="36576" tIns="18288" anchor="t">
+          <a:bodyPr wrap="square" lIns="36576" tIns="18288" rIns="36576" anchor="t">
             <a:spAutoFit/>
           </a:bodyPr>
           <a:lstStyle/>
@@ -10483,6 +10669,7 @@
           <a:lstStyle/>
           <a:p>
             <a:pPr algn="ctr"/>
+            <a:endParaRPr/>
           </a:p>
         </p:txBody>
       </p:sp>
@@ -10503,7 +10690,7 @@
           <a:noFill/>
         </p:spPr>
         <p:txBody>
-          <a:bodyPr wrap="square" lIns="36576" rIns="36576" tIns="18288" anchor="t">
+          <a:bodyPr wrap="square" lIns="36576" tIns="18288" rIns="36576" anchor="t">
             <a:spAutoFit/>
           </a:bodyPr>
           <a:lstStyle/>
@@ -10538,7 +10725,7 @@
           <a:noFill/>
         </p:spPr>
         <p:txBody>
-          <a:bodyPr wrap="square" lIns="36576" rIns="36576" tIns="18288" anchor="t">
+          <a:bodyPr wrap="square" lIns="36576" tIns="18288" rIns="36576" anchor="t">
             <a:spAutoFit/>
           </a:bodyPr>
           <a:lstStyle/>
@@ -10598,6 +10785,7 @@
           <a:lstStyle/>
           <a:p>
             <a:pPr algn="ctr"/>
+            <a:endParaRPr/>
           </a:p>
         </p:txBody>
       </p:sp>
@@ -10618,7 +10806,7 @@
           <a:noFill/>
         </p:spPr>
         <p:txBody>
-          <a:bodyPr wrap="square" lIns="36576" rIns="36576" tIns="18288" anchor="t">
+          <a:bodyPr wrap="square" lIns="36576" tIns="18288" rIns="36576" anchor="t">
             <a:spAutoFit/>
           </a:bodyPr>
           <a:lstStyle/>
@@ -10653,7 +10841,7 @@
           <a:noFill/>
         </p:spPr>
         <p:txBody>
-          <a:bodyPr wrap="square" lIns="36576" rIns="36576" tIns="18288" anchor="t">
+          <a:bodyPr wrap="square" lIns="36576" tIns="18288" rIns="36576" anchor="t">
             <a:spAutoFit/>
           </a:bodyPr>
           <a:lstStyle/>
@@ -10713,6 +10901,7 @@
           <a:lstStyle/>
           <a:p>
             <a:pPr algn="ctr"/>
+            <a:endParaRPr/>
           </a:p>
         </p:txBody>
       </p:sp>
@@ -10733,7 +10922,7 @@
           <a:noFill/>
         </p:spPr>
         <p:txBody>
-          <a:bodyPr wrap="square" lIns="36576" rIns="36576" tIns="18288" anchor="t">
+          <a:bodyPr wrap="square" lIns="36576" tIns="18288" rIns="36576" anchor="t">
             <a:spAutoFit/>
           </a:bodyPr>
           <a:lstStyle/>
@@ -10768,7 +10957,7 @@
           <a:noFill/>
         </p:spPr>
         <p:txBody>
-          <a:bodyPr wrap="square" lIns="36576" rIns="36576" tIns="18288" anchor="t">
+          <a:bodyPr wrap="square" lIns="36576" tIns="18288" rIns="36576" anchor="t">
             <a:spAutoFit/>
           </a:bodyPr>
           <a:lstStyle/>
@@ -10828,6 +11017,7 @@
           <a:lstStyle/>
           <a:p>
             <a:pPr algn="ctr"/>
+            <a:endParaRPr/>
           </a:p>
         </p:txBody>
       </p:sp>
@@ -10848,7 +11038,7 @@
           <a:noFill/>
         </p:spPr>
         <p:txBody>
-          <a:bodyPr wrap="square" lIns="36576" rIns="36576" tIns="18288" anchor="t">
+          <a:bodyPr wrap="square" lIns="36576" tIns="18288" rIns="36576" anchor="t">
             <a:spAutoFit/>
           </a:bodyPr>
           <a:lstStyle/>
@@ -10883,7 +11073,7 @@
           <a:noFill/>
         </p:spPr>
         <p:txBody>
-          <a:bodyPr wrap="square" lIns="36576" rIns="36576" tIns="18288" anchor="t">
+          <a:bodyPr wrap="square" lIns="36576" tIns="18288" rIns="36576" anchor="t">
             <a:spAutoFit/>
           </a:bodyPr>
           <a:lstStyle/>
@@ -10943,6 +11133,7 @@
           <a:lstStyle/>
           <a:p>
             <a:pPr algn="ctr"/>
+            <a:endParaRPr/>
           </a:p>
         </p:txBody>
       </p:sp>
@@ -10963,7 +11154,7 @@
           <a:noFill/>
         </p:spPr>
         <p:txBody>
-          <a:bodyPr wrap="square" lIns="36576" rIns="36576" tIns="18288" anchor="t">
+          <a:bodyPr wrap="square" lIns="36576" tIns="18288" rIns="36576" anchor="t">
             <a:spAutoFit/>
           </a:bodyPr>
           <a:lstStyle/>
@@ -11023,6 +11214,7 @@
           <a:lstStyle/>
           <a:p>
             <a:pPr algn="ctr"/>
+            <a:endParaRPr/>
           </a:p>
         </p:txBody>
       </p:sp>
@@ -11068,6 +11260,7 @@
           <a:lstStyle/>
           <a:p>
             <a:pPr algn="ctr"/>
+            <a:endParaRPr/>
           </a:p>
         </p:txBody>
       </p:sp>
@@ -11088,7 +11281,7 @@
           <a:noFill/>
         </p:spPr>
         <p:txBody>
-          <a:bodyPr wrap="square" lIns="36576" rIns="36576" tIns="18288" anchor="t">
+          <a:bodyPr wrap="square" lIns="36576" tIns="18288" rIns="36576" anchor="t">
             <a:spAutoFit/>
           </a:bodyPr>
           <a:lstStyle/>
@@ -11219,6 +11412,7 @@
           <a:lstStyle/>
           <a:p>
             <a:pPr algn="ctr"/>
+            <a:endParaRPr/>
           </a:p>
         </p:txBody>
       </p:sp>
@@ -11264,6 +11458,7 @@
           <a:lstStyle/>
           <a:p>
             <a:pPr algn="ctr"/>
+            <a:endParaRPr/>
           </a:p>
         </p:txBody>
       </p:sp>
@@ -11284,7 +11479,7 @@
           <a:noFill/>
         </p:spPr>
         <p:txBody>
-          <a:bodyPr wrap="square" lIns="36576" rIns="36576" tIns="18288" anchor="t">
+          <a:bodyPr wrap="square" lIns="36576" tIns="18288" rIns="36576" anchor="t">
             <a:spAutoFit/>
           </a:bodyPr>
           <a:lstStyle/>
@@ -11415,6 +11610,7 @@
           <a:lstStyle/>
           <a:p>
             <a:pPr algn="ctr"/>
+            <a:endParaRPr/>
           </a:p>
         </p:txBody>
       </p:sp>
@@ -11460,6 +11656,7 @@
           <a:lstStyle/>
           <a:p>
             <a:pPr algn="ctr"/>
+            <a:endParaRPr/>
           </a:p>
         </p:txBody>
       </p:sp>
@@ -11480,7 +11677,7 @@
           <a:noFill/>
         </p:spPr>
         <p:txBody>
-          <a:bodyPr wrap="square" lIns="36576" rIns="36576" tIns="18288" anchor="t">
+          <a:bodyPr wrap="square" lIns="36576" tIns="18288" rIns="36576" anchor="t">
             <a:spAutoFit/>
           </a:bodyPr>
           <a:lstStyle/>
@@ -11586,7 +11783,7 @@
           <a:noFill/>
         </p:spPr>
         <p:txBody>
-          <a:bodyPr wrap="square" lIns="36576" rIns="36576" tIns="18288" anchor="t">
+          <a:bodyPr wrap="square" lIns="36576" tIns="18288" rIns="36576" anchor="t">
             <a:spAutoFit/>
           </a:bodyPr>
           <a:lstStyle/>
@@ -11609,11 +11806,18 @@
   <p:clrMapOvr>
     <a:masterClrMapping/>
   </p:clrMapOvr>
+  <p:timing>
+    <p:tnLst>
+      <p:par>
+        <p:cTn id="1" dur="indefinite" restart="never" nodeType="tmRoot"/>
+      </p:par>
+    </p:tnLst>
+  </p:timing>
 </p:sld>
 </file>
 
 <file path=ppt/slides/slide7.xml><?xml version="1.0" encoding="utf-8"?>
-<p:sld xmlns:a="http://schemas.openxmlformats.org/drawingml/2006/main" xmlns:p="http://schemas.openxmlformats.org/presentationml/2006/main" xmlns:r="http://schemas.openxmlformats.org/officeDocument/2006/relationships">
+<p:sld xmlns:a="http://schemas.openxmlformats.org/drawingml/2006/main" xmlns:r="http://schemas.openxmlformats.org/officeDocument/2006/relationships" xmlns:p="http://schemas.openxmlformats.org/presentationml/2006/main">
   <p:cSld>
     <p:bg>
       <p:bgPr>
@@ -11629,7 +11833,14 @@
         <p:cNvGrpSpPr/>
         <p:nvPr/>
       </p:nvGrpSpPr>
-      <p:grpSpPr/>
+      <p:grpSpPr>
+        <a:xfrm>
+          <a:off x="0" y="0"/>
+          <a:ext cx="0" cy="0"/>
+          <a:chOff x="0" y="0"/>
+          <a:chExt cx="0" cy="0"/>
+        </a:xfrm>
+      </p:grpSpPr>
       <p:sp>
         <p:nvSpPr>
           <p:cNvPr id="2" name="Rectangle 1"/>
@@ -11672,6 +11883,7 @@
           <a:lstStyle/>
           <a:p>
             <a:pPr algn="ctr"/>
+            <a:endParaRPr/>
           </a:p>
         </p:txBody>
       </p:sp>
@@ -11692,7 +11904,7 @@
           <a:noFill/>
         </p:spPr>
         <p:txBody>
-          <a:bodyPr wrap="square" lIns="36576" rIns="36576" tIns="18288" anchor="t">
+          <a:bodyPr wrap="square" lIns="36576" tIns="18288" rIns="36576" anchor="t">
             <a:spAutoFit/>
           </a:bodyPr>
           <a:lstStyle/>
@@ -11727,7 +11939,7 @@
           <a:noFill/>
         </p:spPr>
         <p:txBody>
-          <a:bodyPr wrap="square" lIns="36576" rIns="36576" tIns="18288" anchor="t">
+          <a:bodyPr wrap="square" lIns="36576" tIns="18288" rIns="36576" anchor="t">
             <a:spAutoFit/>
           </a:bodyPr>
           <a:lstStyle/>
@@ -11762,7 +11974,7 @@
           <a:noFill/>
         </p:spPr>
         <p:txBody>
-          <a:bodyPr wrap="square" lIns="36576" rIns="36576" tIns="18288" anchor="t">
+          <a:bodyPr wrap="square" lIns="36576" tIns="18288" rIns="36576" anchor="t">
             <a:spAutoFit/>
           </a:bodyPr>
           <a:lstStyle/>
@@ -11797,7 +12009,7 @@
           <a:noFill/>
         </p:spPr>
         <p:txBody>
-          <a:bodyPr wrap="square" lIns="36576" rIns="36576" tIns="18288" anchor="t">
+          <a:bodyPr wrap="square" lIns="36576" tIns="18288" rIns="36576" anchor="t">
             <a:spAutoFit/>
           </a:bodyPr>
           <a:lstStyle/>
@@ -11832,7 +12044,7 @@
           <a:noFill/>
         </p:spPr>
         <p:txBody>
-          <a:bodyPr wrap="square" lIns="36576" rIns="36576" tIns="18288" anchor="t">
+          <a:bodyPr wrap="square" lIns="36576" tIns="18288" rIns="36576" anchor="t">
             <a:spAutoFit/>
           </a:bodyPr>
           <a:lstStyle/>
@@ -11892,6 +12104,7 @@
           <a:lstStyle/>
           <a:p>
             <a:pPr algn="ctr"/>
+            <a:endParaRPr/>
           </a:p>
         </p:txBody>
       </p:sp>
@@ -11912,7 +12125,7 @@
           <a:noFill/>
         </p:spPr>
         <p:txBody>
-          <a:bodyPr wrap="square" lIns="36576" rIns="36576" tIns="18288" anchor="t">
+          <a:bodyPr wrap="square" lIns="36576" tIns="18288" rIns="36576" anchor="t">
             <a:spAutoFit/>
           </a:bodyPr>
           <a:lstStyle/>
@@ -11947,7 +12160,7 @@
           <a:noFill/>
         </p:spPr>
         <p:txBody>
-          <a:bodyPr wrap="square" lIns="36576" rIns="36576" tIns="18288" anchor="t">
+          <a:bodyPr wrap="square" lIns="36576" tIns="18288" rIns="36576" anchor="t">
             <a:spAutoFit/>
           </a:bodyPr>
           <a:lstStyle/>
@@ -12007,6 +12220,7 @@
           <a:lstStyle/>
           <a:p>
             <a:pPr algn="ctr"/>
+            <a:endParaRPr/>
           </a:p>
         </p:txBody>
       </p:sp>
@@ -12027,7 +12241,7 @@
           <a:noFill/>
         </p:spPr>
         <p:txBody>
-          <a:bodyPr wrap="square" lIns="36576" rIns="36576" tIns="18288" anchor="t">
+          <a:bodyPr wrap="square" lIns="36576" tIns="18288" rIns="36576" anchor="t">
             <a:spAutoFit/>
           </a:bodyPr>
           <a:lstStyle/>
@@ -12062,7 +12276,7 @@
           <a:noFill/>
         </p:spPr>
         <p:txBody>
-          <a:bodyPr wrap="square" lIns="36576" rIns="36576" tIns="18288" anchor="t">
+          <a:bodyPr wrap="square" lIns="36576" tIns="18288" rIns="36576" anchor="t">
             <a:spAutoFit/>
           </a:bodyPr>
           <a:lstStyle/>
@@ -12122,6 +12336,7 @@
           <a:lstStyle/>
           <a:p>
             <a:pPr algn="ctr"/>
+            <a:endParaRPr/>
           </a:p>
         </p:txBody>
       </p:sp>
@@ -12142,7 +12357,7 @@
           <a:noFill/>
         </p:spPr>
         <p:txBody>
-          <a:bodyPr wrap="square" lIns="36576" rIns="36576" tIns="18288" anchor="t">
+          <a:bodyPr wrap="square" lIns="36576" tIns="18288" rIns="36576" anchor="t">
             <a:spAutoFit/>
           </a:bodyPr>
           <a:lstStyle/>
@@ -12177,7 +12392,7 @@
           <a:noFill/>
         </p:spPr>
         <p:txBody>
-          <a:bodyPr wrap="square" lIns="36576" rIns="36576" tIns="18288" anchor="t">
+          <a:bodyPr wrap="square" lIns="36576" tIns="18288" rIns="36576" anchor="t">
             <a:spAutoFit/>
           </a:bodyPr>
           <a:lstStyle/>
@@ -12237,6 +12452,7 @@
           <a:lstStyle/>
           <a:p>
             <a:pPr algn="ctr"/>
+            <a:endParaRPr/>
           </a:p>
         </p:txBody>
       </p:sp>
@@ -12257,7 +12473,7 @@
           <a:noFill/>
         </p:spPr>
         <p:txBody>
-          <a:bodyPr wrap="square" lIns="36576" rIns="36576" tIns="18288" anchor="t">
+          <a:bodyPr wrap="square" lIns="36576" tIns="18288" rIns="36576" anchor="t">
             <a:spAutoFit/>
           </a:bodyPr>
           <a:lstStyle/>
@@ -12317,6 +12533,7 @@
           <a:lstStyle/>
           <a:p>
             <a:pPr algn="ctr"/>
+            <a:endParaRPr/>
           </a:p>
         </p:txBody>
       </p:sp>
@@ -12362,6 +12579,7 @@
           <a:lstStyle/>
           <a:p>
             <a:pPr algn="ctr"/>
+            <a:endParaRPr/>
           </a:p>
         </p:txBody>
       </p:sp>
@@ -12382,7 +12600,7 @@
           <a:noFill/>
         </p:spPr>
         <p:txBody>
-          <a:bodyPr wrap="square" lIns="36576" rIns="36576" tIns="18288" anchor="t">
+          <a:bodyPr wrap="square" lIns="36576" tIns="18288" rIns="36576" anchor="t">
             <a:spAutoFit/>
           </a:bodyPr>
           <a:lstStyle/>
@@ -12409,22 +12627,22 @@
         <p:spPr>
           <a:xfrm>
             <a:off x="8183879" y="2496312"/>
-            <a:ext cx="2971800" cy="1536192"/>
-          </a:xfrm>
-          <a:prstGeom prst="rect">
-            <a:avLst/>
-          </a:prstGeom>
-          <a:noFill/>
-        </p:spPr>
-        <p:txBody>
-          <a:bodyPr wrap="square" lIns="36576" rIns="36576" tIns="18288" anchor="t">
+            <a:ext cx="2971800" cy="1141851"/>
+          </a:xfrm>
+          <a:prstGeom prst="rect">
+            <a:avLst/>
+          </a:prstGeom>
+          <a:noFill/>
+        </p:spPr>
+        <p:txBody>
+          <a:bodyPr wrap="square" lIns="36576" tIns="18288" rIns="36576" anchor="t">
             <a:spAutoFit/>
           </a:bodyPr>
           <a:lstStyle/>
           <a:p>
             <a:pPr algn="l"/>
             <a:r>
-              <a:rPr sz="1500" b="0">
+              <a:rPr sz="1400" b="0" dirty="0">
                 <a:solidFill>
                   <a:srgbClr val="AABCC6"/>
                 </a:solidFill>
@@ -12477,6 +12695,7 @@
           <a:lstStyle/>
           <a:p>
             <a:pPr algn="ctr"/>
+            <a:endParaRPr/>
           </a:p>
         </p:txBody>
       </p:sp>
@@ -12522,6 +12741,7 @@
           <a:lstStyle/>
           <a:p>
             <a:pPr algn="ctr"/>
+            <a:endParaRPr/>
           </a:p>
         </p:txBody>
       </p:sp>
@@ -12542,7 +12762,7 @@
           <a:noFill/>
         </p:spPr>
         <p:txBody>
-          <a:bodyPr wrap="square" lIns="36576" rIns="36576" tIns="18288" anchor="t">
+          <a:bodyPr wrap="square" lIns="36576" tIns="18288" rIns="36576" anchor="t">
             <a:spAutoFit/>
           </a:bodyPr>
           <a:lstStyle/>
@@ -12568,23 +12788,23 @@
         </p:nvSpPr>
         <p:spPr>
           <a:xfrm>
-            <a:off x="8183879" y="5056631"/>
-            <a:ext cx="2971800" cy="576072"/>
-          </a:xfrm>
-          <a:prstGeom prst="rect">
-            <a:avLst/>
-          </a:prstGeom>
-          <a:noFill/>
-        </p:spPr>
-        <p:txBody>
-          <a:bodyPr wrap="square" lIns="36576" rIns="36576" tIns="18288" anchor="t">
+            <a:off x="8183879" y="4937760"/>
+            <a:ext cx="2971800" cy="803297"/>
+          </a:xfrm>
+          <a:prstGeom prst="rect">
+            <a:avLst/>
+          </a:prstGeom>
+          <a:noFill/>
+        </p:spPr>
+        <p:txBody>
+          <a:bodyPr wrap="square" lIns="36576" tIns="18288" rIns="36576" anchor="t">
             <a:spAutoFit/>
           </a:bodyPr>
           <a:lstStyle/>
           <a:p>
             <a:pPr algn="l"/>
             <a:r>
-              <a:rPr sz="1300" b="0">
+              <a:rPr sz="1200" b="0" dirty="0">
                 <a:solidFill>
                   <a:srgbClr val="AABCC6"/>
                 </a:solidFill>
@@ -12600,11 +12820,18 @@
   <p:clrMapOvr>
     <a:masterClrMapping/>
   </p:clrMapOvr>
+  <p:timing>
+    <p:tnLst>
+      <p:par>
+        <p:cTn id="1" dur="indefinite" restart="never" nodeType="tmRoot"/>
+      </p:par>
+    </p:tnLst>
+  </p:timing>
 </p:sld>
 </file>
 
 <file path=ppt/slides/slide8.xml><?xml version="1.0" encoding="utf-8"?>
-<p:sld xmlns:a="http://schemas.openxmlformats.org/drawingml/2006/main" xmlns:p="http://schemas.openxmlformats.org/presentationml/2006/main" xmlns:r="http://schemas.openxmlformats.org/officeDocument/2006/relationships">
+<p:sld xmlns:a="http://schemas.openxmlformats.org/drawingml/2006/main" xmlns:r="http://schemas.openxmlformats.org/officeDocument/2006/relationships" xmlns:p="http://schemas.openxmlformats.org/presentationml/2006/main">
   <p:cSld>
     <p:bg>
       <p:bgPr>
@@ -12620,7 +12847,14 @@
         <p:cNvGrpSpPr/>
         <p:nvPr/>
       </p:nvGrpSpPr>
-      <p:grpSpPr/>
+      <p:grpSpPr>
+        <a:xfrm>
+          <a:off x="0" y="0"/>
+          <a:ext cx="0" cy="0"/>
+          <a:chOff x="0" y="0"/>
+          <a:chExt cx="0" cy="0"/>
+        </a:xfrm>
+      </p:grpSpPr>
       <p:sp>
         <p:nvSpPr>
           <p:cNvPr id="2" name="Rectangle 1"/>
@@ -12663,6 +12897,7 @@
           <a:lstStyle/>
           <a:p>
             <a:pPr algn="ctr"/>
+            <a:endParaRPr/>
           </a:p>
         </p:txBody>
       </p:sp>
@@ -12683,7 +12918,7 @@
           <a:noFill/>
         </p:spPr>
         <p:txBody>
-          <a:bodyPr wrap="square" lIns="36576" rIns="36576" tIns="18288" anchor="t">
+          <a:bodyPr wrap="square" lIns="36576" tIns="18288" rIns="36576" anchor="t">
             <a:spAutoFit/>
           </a:bodyPr>
           <a:lstStyle/>
@@ -12718,7 +12953,7 @@
           <a:noFill/>
         </p:spPr>
         <p:txBody>
-          <a:bodyPr wrap="square" lIns="36576" rIns="36576" tIns="18288" anchor="t">
+          <a:bodyPr wrap="square" lIns="36576" tIns="18288" rIns="36576" anchor="t">
             <a:spAutoFit/>
           </a:bodyPr>
           <a:lstStyle/>
@@ -12753,7 +12988,7 @@
           <a:noFill/>
         </p:spPr>
         <p:txBody>
-          <a:bodyPr wrap="square" lIns="36576" rIns="36576" tIns="18288" anchor="t">
+          <a:bodyPr wrap="square" lIns="36576" tIns="18288" rIns="36576" anchor="t">
             <a:spAutoFit/>
           </a:bodyPr>
           <a:lstStyle/>
@@ -12788,7 +13023,7 @@
           <a:noFill/>
         </p:spPr>
         <p:txBody>
-          <a:bodyPr wrap="square" lIns="36576" rIns="36576" tIns="18288" anchor="t">
+          <a:bodyPr wrap="square" lIns="36576" tIns="18288" rIns="36576" anchor="t">
             <a:spAutoFit/>
           </a:bodyPr>
           <a:lstStyle/>
@@ -12823,7 +13058,7 @@
           <a:noFill/>
         </p:spPr>
         <p:txBody>
-          <a:bodyPr wrap="square" lIns="36576" rIns="36576" tIns="18288" anchor="t">
+          <a:bodyPr wrap="square" lIns="36576" tIns="18288" rIns="36576" anchor="t">
             <a:spAutoFit/>
           </a:bodyPr>
           <a:lstStyle/>
@@ -12858,7 +13093,7 @@
           <a:noFill/>
         </p:spPr>
         <p:txBody>
-          <a:bodyPr wrap="square" lIns="36576" rIns="36576" tIns="18288" anchor="t">
+          <a:bodyPr wrap="square" lIns="36576" tIns="18288" rIns="36576" anchor="t">
             <a:spAutoFit/>
           </a:bodyPr>
           <a:lstStyle/>
@@ -12893,7 +13128,7 @@
           <a:noFill/>
         </p:spPr>
         <p:txBody>
-          <a:bodyPr wrap="square" lIns="36576" rIns="36576" tIns="18288" anchor="t">
+          <a:bodyPr wrap="square" lIns="36576" tIns="18288" rIns="36576" anchor="t">
             <a:spAutoFit/>
           </a:bodyPr>
           <a:lstStyle/>
@@ -12928,7 +13163,7 @@
           <a:noFill/>
         </p:spPr>
         <p:txBody>
-          <a:bodyPr wrap="square" lIns="36576" rIns="36576" tIns="18288" anchor="t">
+          <a:bodyPr wrap="square" lIns="36576" tIns="18288" rIns="36576" anchor="t">
             <a:spAutoFit/>
           </a:bodyPr>
           <a:lstStyle/>
@@ -12963,7 +13198,7 @@
           <a:noFill/>
         </p:spPr>
         <p:txBody>
-          <a:bodyPr wrap="square" lIns="36576" rIns="36576" tIns="18288" anchor="t">
+          <a:bodyPr wrap="square" lIns="36576" tIns="18288" rIns="36576" anchor="t">
             <a:spAutoFit/>
           </a:bodyPr>
           <a:lstStyle/>
@@ -12998,7 +13233,7 @@
           <a:noFill/>
         </p:spPr>
         <p:txBody>
-          <a:bodyPr wrap="square" lIns="36576" rIns="36576" tIns="18288" anchor="t">
+          <a:bodyPr wrap="square" lIns="36576" tIns="18288" rIns="36576" anchor="t">
             <a:spAutoFit/>
           </a:bodyPr>
           <a:lstStyle/>
@@ -13033,7 +13268,7 @@
           <a:noFill/>
         </p:spPr>
         <p:txBody>
-          <a:bodyPr wrap="square" lIns="36576" rIns="36576" tIns="18288" anchor="t">
+          <a:bodyPr wrap="square" lIns="36576" tIns="18288" rIns="36576" anchor="t">
             <a:spAutoFit/>
           </a:bodyPr>
           <a:lstStyle/>
@@ -13068,7 +13303,7 @@
           <a:noFill/>
         </p:spPr>
         <p:txBody>
-          <a:bodyPr wrap="square" lIns="36576" rIns="36576" tIns="18288" anchor="t">
+          <a:bodyPr wrap="square" lIns="36576" tIns="18288" rIns="36576" anchor="t">
             <a:spAutoFit/>
           </a:bodyPr>
           <a:lstStyle/>
@@ -13103,7 +13338,7 @@
           <a:noFill/>
         </p:spPr>
         <p:txBody>
-          <a:bodyPr wrap="square" lIns="36576" rIns="36576" tIns="18288" anchor="t">
+          <a:bodyPr wrap="square" lIns="36576" tIns="18288" rIns="36576" anchor="t">
             <a:spAutoFit/>
           </a:bodyPr>
           <a:lstStyle/>
@@ -13129,8 +13364,8 @@
         </p:nvSpPr>
         <p:spPr>
           <a:xfrm>
-            <a:off x="2103120" y="3794760"/>
-            <a:ext cx="7955279" cy="1325880"/>
+            <a:off x="2103120" y="3794759"/>
+            <a:ext cx="7955279" cy="1446107"/>
           </a:xfrm>
           <a:prstGeom prst="roundRect">
             <a:avLst/>
@@ -13163,6 +13398,7 @@
           <a:lstStyle/>
           <a:p>
             <a:pPr algn="ctr"/>
+            <a:endParaRPr/>
           </a:p>
         </p:txBody>
       </p:sp>
@@ -13208,6 +13444,7 @@
           <a:lstStyle/>
           <a:p>
             <a:pPr algn="ctr"/>
+            <a:endParaRPr/>
           </a:p>
         </p:txBody>
       </p:sp>
@@ -13228,7 +13465,7 @@
           <a:noFill/>
         </p:spPr>
         <p:txBody>
-          <a:bodyPr wrap="square" lIns="36576" rIns="36576" tIns="18288" anchor="t">
+          <a:bodyPr wrap="square" lIns="36576" tIns="18288" rIns="36576" anchor="t">
             <a:spAutoFit/>
           </a:bodyPr>
           <a:lstStyle/>
@@ -13254,8 +13491,8 @@
         </p:nvSpPr>
         <p:spPr>
           <a:xfrm>
-            <a:off x="2331720" y="4416552"/>
-            <a:ext cx="7543800" cy="576072"/>
+            <a:off x="2331720" y="4240090"/>
+            <a:ext cx="7543800" cy="877163"/>
           </a:xfrm>
           <a:prstGeom prst="rect">
             <a:avLst/>
@@ -13280,6 +13517,7 @@
               </a:defRPr>
             </a:pPr>
             <a:r>
+              <a:rPr sz="1200" dirty="0"/>
               <a:t>•  Eight synthetic cases; not a production accuracy estimate</a:t>
             </a:r>
           </a:p>
@@ -13296,6 +13534,7 @@
               </a:defRPr>
             </a:pPr>
             <a:r>
+              <a:rPr sz="1200" dirty="0"/>
               <a:t>•  Perfect score agreement does not mean extraction fields were all correct</a:t>
             </a:r>
           </a:p>
@@ -13312,6 +13551,7 @@
               </a:defRPr>
             </a:pPr>
             <a:r>
+              <a:rPr sz="1200" dirty="0"/>
               <a:t>•  Field-level errors remain visible for prompt iteration</a:t>
             </a:r>
           </a:p>
@@ -13322,11 +13562,18 @@
   <p:clrMapOvr>
     <a:masterClrMapping/>
   </p:clrMapOvr>
+  <p:timing>
+    <p:tnLst>
+      <p:par>
+        <p:cTn id="1" dur="indefinite" restart="never" nodeType="tmRoot"/>
+      </p:par>
+    </p:tnLst>
+  </p:timing>
 </p:sld>
 </file>
 
 <file path=ppt/slides/slide9.xml><?xml version="1.0" encoding="utf-8"?>
-<p:sld xmlns:a="http://schemas.openxmlformats.org/drawingml/2006/main" xmlns:p="http://schemas.openxmlformats.org/presentationml/2006/main" xmlns:r="http://schemas.openxmlformats.org/officeDocument/2006/relationships">
+<p:sld xmlns:a="http://schemas.openxmlformats.org/drawingml/2006/main" xmlns:r="http://schemas.openxmlformats.org/officeDocument/2006/relationships" xmlns:p="http://schemas.openxmlformats.org/presentationml/2006/main">
   <p:cSld>
     <p:bg>
       <p:bgPr>
@@ -13342,7 +13589,14 @@
         <p:cNvGrpSpPr/>
         <p:nvPr/>
       </p:nvGrpSpPr>
-      <p:grpSpPr/>
+      <p:grpSpPr>
+        <a:xfrm>
+          <a:off x="0" y="0"/>
+          <a:ext cx="0" cy="0"/>
+          <a:chOff x="0" y="0"/>
+          <a:chExt cx="0" cy="0"/>
+        </a:xfrm>
+      </p:grpSpPr>
       <p:sp>
         <p:nvSpPr>
           <p:cNvPr id="2" name="Rectangle 1"/>
@@ -13385,6 +13639,7 @@
           <a:lstStyle/>
           <a:p>
             <a:pPr algn="ctr"/>
+            <a:endParaRPr/>
           </a:p>
         </p:txBody>
       </p:sp>
@@ -13405,7 +13660,7 @@
           <a:noFill/>
         </p:spPr>
         <p:txBody>
-          <a:bodyPr wrap="square" lIns="36576" rIns="36576" tIns="18288" anchor="t">
+          <a:bodyPr wrap="square" lIns="36576" tIns="18288" rIns="36576" anchor="t">
             <a:spAutoFit/>
           </a:bodyPr>
           <a:lstStyle/>
@@ -13440,7 +13695,7 @@
           <a:noFill/>
         </p:spPr>
         <p:txBody>
-          <a:bodyPr wrap="square" lIns="36576" rIns="36576" tIns="18288" anchor="t">
+          <a:bodyPr wrap="square" lIns="36576" tIns="18288" rIns="36576" anchor="t">
             <a:spAutoFit/>
           </a:bodyPr>
           <a:lstStyle/>
@@ -13475,7 +13730,7 @@
           <a:noFill/>
         </p:spPr>
         <p:txBody>
-          <a:bodyPr wrap="square" lIns="36576" rIns="36576" tIns="18288" anchor="t">
+          <a:bodyPr wrap="square" lIns="36576" tIns="18288" rIns="36576" anchor="t">
             <a:spAutoFit/>
           </a:bodyPr>
           <a:lstStyle/>
@@ -13510,7 +13765,7 @@
           <a:noFill/>
         </p:spPr>
         <p:txBody>
-          <a:bodyPr wrap="square" lIns="36576" rIns="36576" tIns="18288" anchor="t">
+          <a:bodyPr wrap="square" lIns="36576" tIns="18288" rIns="36576" anchor="t">
             <a:spAutoFit/>
           </a:bodyPr>
           <a:lstStyle/>
@@ -13570,6 +13825,7 @@
           <a:lstStyle/>
           <a:p>
             <a:pPr algn="ctr"/>
+            <a:endParaRPr/>
           </a:p>
         </p:txBody>
       </p:sp>
@@ -13590,7 +13846,7 @@
           <a:noFill/>
         </p:spPr>
         <p:txBody>
-          <a:bodyPr wrap="square" lIns="36576" rIns="36576" tIns="18288" anchor="t">
+          <a:bodyPr wrap="square" lIns="36576" tIns="18288" rIns="36576" anchor="t">
             <a:spAutoFit/>
           </a:bodyPr>
           <a:lstStyle/>
@@ -13625,7 +13881,7 @@
           <a:noFill/>
         </p:spPr>
         <p:txBody>
-          <a:bodyPr wrap="square" lIns="36576" rIns="36576" tIns="18288" anchor="t">
+          <a:bodyPr wrap="square" lIns="36576" tIns="18288" rIns="36576" anchor="t">
             <a:spAutoFit/>
           </a:bodyPr>
           <a:lstStyle/>
@@ -13660,7 +13916,7 @@
           <a:noFill/>
         </p:spPr>
         <p:txBody>
-          <a:bodyPr wrap="square" lIns="36576" rIns="36576" tIns="18288" anchor="t">
+          <a:bodyPr wrap="square" lIns="36576" tIns="18288" rIns="36576" anchor="t">
             <a:spAutoFit/>
           </a:bodyPr>
           <a:lstStyle/>
@@ -13720,6 +13976,7 @@
           <a:lstStyle/>
           <a:p>
             <a:pPr algn="ctr"/>
+            <a:endParaRPr/>
           </a:p>
         </p:txBody>
       </p:sp>
@@ -13740,7 +13997,7 @@
           <a:noFill/>
         </p:spPr>
         <p:txBody>
-          <a:bodyPr wrap="square" lIns="36576" rIns="36576" tIns="18288" anchor="t">
+          <a:bodyPr wrap="square" lIns="36576" tIns="18288" rIns="36576" anchor="t">
             <a:spAutoFit/>
           </a:bodyPr>
           <a:lstStyle/>
@@ -13775,7 +14032,7 @@
           <a:noFill/>
         </p:spPr>
         <p:txBody>
-          <a:bodyPr wrap="square" lIns="36576" rIns="36576" tIns="18288" anchor="t">
+          <a:bodyPr wrap="square" lIns="36576" tIns="18288" rIns="36576" anchor="t">
             <a:spAutoFit/>
           </a:bodyPr>
           <a:lstStyle/>
@@ -13810,7 +14067,7 @@
           <a:noFill/>
         </p:spPr>
         <p:txBody>
-          <a:bodyPr wrap="square" lIns="36576" rIns="36576" tIns="18288" anchor="t">
+          <a:bodyPr wrap="square" lIns="36576" tIns="18288" rIns="36576" anchor="t">
             <a:spAutoFit/>
           </a:bodyPr>
           <a:lstStyle/>
@@ -13870,6 +14127,7 @@
           <a:lstStyle/>
           <a:p>
             <a:pPr algn="ctr"/>
+            <a:endParaRPr/>
           </a:p>
         </p:txBody>
       </p:sp>
@@ -13890,7 +14148,7 @@
           <a:noFill/>
         </p:spPr>
         <p:txBody>
-          <a:bodyPr wrap="square" lIns="36576" rIns="36576" tIns="18288" anchor="t">
+          <a:bodyPr wrap="square" lIns="36576" tIns="18288" rIns="36576" anchor="t">
             <a:spAutoFit/>
           </a:bodyPr>
           <a:lstStyle/>
@@ -13925,7 +14183,7 @@
           <a:noFill/>
         </p:spPr>
         <p:txBody>
-          <a:bodyPr wrap="square" lIns="36576" rIns="36576" tIns="18288" anchor="t">
+          <a:bodyPr wrap="square" lIns="36576" tIns="18288" rIns="36576" anchor="t">
             <a:spAutoFit/>
           </a:bodyPr>
           <a:lstStyle/>
@@ -13960,7 +14218,7 @@
           <a:noFill/>
         </p:spPr>
         <p:txBody>
-          <a:bodyPr wrap="square" lIns="36576" rIns="36576" tIns="18288" anchor="t">
+          <a:bodyPr wrap="square" lIns="36576" tIns="18288" rIns="36576" anchor="t">
             <a:spAutoFit/>
           </a:bodyPr>
           <a:lstStyle/>
@@ -14020,6 +14278,7 @@
           <a:lstStyle/>
           <a:p>
             <a:pPr algn="ctr"/>
+            <a:endParaRPr/>
           </a:p>
         </p:txBody>
       </p:sp>
@@ -14040,7 +14299,7 @@
           <a:noFill/>
         </p:spPr>
         <p:txBody>
-          <a:bodyPr wrap="square" lIns="36576" rIns="36576" tIns="18288" anchor="t">
+          <a:bodyPr wrap="square" lIns="36576" tIns="18288" rIns="36576" anchor="t">
             <a:spAutoFit/>
           </a:bodyPr>
           <a:lstStyle/>
@@ -14075,7 +14334,7 @@
           <a:noFill/>
         </p:spPr>
         <p:txBody>
-          <a:bodyPr wrap="square" lIns="36576" rIns="36576" tIns="18288" anchor="t">
+          <a:bodyPr wrap="square" lIns="36576" tIns="18288" rIns="36576" anchor="t">
             <a:spAutoFit/>
           </a:bodyPr>
           <a:lstStyle/>
@@ -14110,7 +14369,7 @@
           <a:noFill/>
         </p:spPr>
         <p:txBody>
-          <a:bodyPr wrap="square" lIns="36576" rIns="36576" tIns="18288" anchor="t">
+          <a:bodyPr wrap="square" lIns="36576" tIns="18288" rIns="36576" anchor="t">
             <a:spAutoFit/>
           </a:bodyPr>
           <a:lstStyle/>
@@ -14170,6 +14429,7 @@
           <a:lstStyle/>
           <a:p>
             <a:pPr algn="ctr"/>
+            <a:endParaRPr/>
           </a:p>
         </p:txBody>
       </p:sp>
@@ -14190,7 +14450,7 @@
           <a:noFill/>
         </p:spPr>
         <p:txBody>
-          <a:bodyPr wrap="square" lIns="36576" rIns="36576" tIns="18288" anchor="t">
+          <a:bodyPr wrap="square" lIns="36576" tIns="18288" rIns="36576" anchor="t">
             <a:spAutoFit/>
           </a:bodyPr>
           <a:lstStyle/>
@@ -14225,7 +14485,7 @@
           <a:noFill/>
         </p:spPr>
         <p:txBody>
-          <a:bodyPr wrap="square" lIns="36576" rIns="36576" tIns="18288" anchor="t">
+          <a:bodyPr wrap="square" lIns="36576" tIns="18288" rIns="36576" anchor="t">
             <a:spAutoFit/>
           </a:bodyPr>
           <a:lstStyle/>
@@ -14260,7 +14520,7 @@
           <a:noFill/>
         </p:spPr>
         <p:txBody>
-          <a:bodyPr wrap="square" lIns="36576" rIns="36576" tIns="18288" anchor="t">
+          <a:bodyPr wrap="square" lIns="36576" tIns="18288" rIns="36576" anchor="t">
             <a:spAutoFit/>
           </a:bodyPr>
           <a:lstStyle/>
@@ -14320,6 +14580,7 @@
           <a:lstStyle/>
           <a:p>
             <a:pPr algn="ctr"/>
+            <a:endParaRPr/>
           </a:p>
         </p:txBody>
       </p:sp>
@@ -14340,7 +14601,7 @@
           <a:noFill/>
         </p:spPr>
         <p:txBody>
-          <a:bodyPr wrap="square" lIns="36576" rIns="36576" tIns="18288" anchor="t">
+          <a:bodyPr wrap="square" lIns="36576" tIns="18288" rIns="36576" anchor="t">
             <a:spAutoFit/>
           </a:bodyPr>
           <a:lstStyle/>
@@ -14375,7 +14636,7 @@
           <a:noFill/>
         </p:spPr>
         <p:txBody>
-          <a:bodyPr wrap="square" lIns="36576" rIns="36576" tIns="18288" anchor="t">
+          <a:bodyPr wrap="square" lIns="36576" tIns="18288" rIns="36576" anchor="t">
             <a:spAutoFit/>
           </a:bodyPr>
           <a:lstStyle/>
@@ -14410,7 +14671,7 @@
           <a:noFill/>
         </p:spPr>
         <p:txBody>
-          <a:bodyPr wrap="square" lIns="36576" rIns="36576" tIns="18288" anchor="t">
+          <a:bodyPr wrap="square" lIns="36576" tIns="18288" rIns="36576" anchor="t">
             <a:spAutoFit/>
           </a:bodyPr>
           <a:lstStyle/>
@@ -14445,7 +14706,7 @@
           <a:noFill/>
         </p:spPr>
         <p:txBody>
-          <a:bodyPr wrap="square" lIns="36576" rIns="36576" tIns="18288" anchor="t">
+          <a:bodyPr wrap="square" lIns="36576" tIns="18288" rIns="36576" anchor="t">
             <a:spAutoFit/>
           </a:bodyPr>
           <a:lstStyle/>
@@ -14468,6 +14729,13 @@
   <p:clrMapOvr>
     <a:masterClrMapping/>
   </p:clrMapOvr>
+  <p:timing>
+    <p:tnLst>
+      <p:par>
+        <p:cTn id="1" dur="indefinite" restart="never" nodeType="tmRoot"/>
+      </p:par>
+    </p:tnLst>
+  </p:timing>
 </p:sld>
 </file>
 

</xml_diff>

<commit_message>
addressed the gaps from the audit. I will have this tested at home since office network does not allow API calls
</commit_message>
<xml_diff>
--- a/docs/presentation/Risk_Assessment_Workbench_Genius_Hacks_2026.pptx
+++ b/docs/presentation/Risk_Assessment_Workbench_Genius_Hacks_2026.pptx
@@ -1572,7 +1572,7 @@
           <a:lstStyle/>
           <a:p>
             <a:r>
-              <a:t>7:45-9:45. Lead with the iteration story: baseline, what was classified as wrong, what changed, new number. Then failure handling: the office-network block, how it was detected (APIConnectionError, 0/8) and the recovery. Token line: gpt-4o-mini, bounded input, per-call latency and token telemetry; quote measured tokens per case from the iteration log.</a:t>
+              <a:t>7:45-9:45. Lead with the iteration story: baseline, what was classified as wrong, what changed, new number. Then failure handling: the office-network block, how it was detected (APIConnectionError, 0/8), recovery, and the bounded runtime retry added after testing. Also mention malformed PDFs now return a controlled 422. Token line: gpt-4o-mini, bounded input, per-call latency and token telemetry; quote measured tokens per case from the iteration log.</a:t>
             </a:r>
           </a:p>
         </p:txBody>
@@ -11525,7 +11525,7 @@
                 </a:solidFill>
                 <a:latin typeface="Calibri"/>
               </a:rPr>
-              <a:t>Approve / reject / conditions</a:t>
+              <a:t>Approve / reject / defer / conditions</a:t>
             </a:r>
           </a:p>
           <a:p>
@@ -11542,7 +11542,7 @@
                 </a:solidFill>
                 <a:latin typeface="Calibri"/>
               </a:rPr>
-              <a:t>Two approvals approve; otherwise reject</a:t>
+              <a:t>Two approvals/rejections decide; otherwise defer</a:t>
             </a:r>
           </a:p>
         </p:txBody>
@@ -13609,7 +13609,7 @@
                 </a:solidFill>
                 <a:latin typeface="Calibri"/>
               </a:rPr>
-              <a:t>First live run: 0/8, connection errors. Cause: office network blocks the OpenAI API. Fix: ran from another network</a:t>
+              <a:t>Office-network incident: 0/8; recovered on an unblocked network. Runtime now retries transient provider failures up to three times</a:t>
             </a:r>
           </a:p>
           <a:p>
@@ -13643,7 +13643,7 @@
                 </a:solidFill>
                 <a:latin typeface="Calibri"/>
               </a:rPr>
-              <a:t>Eight synthetic cases, not a production accuracy estimate. pytest: not verified</a:t>
+              <a:t>Eight synthetic cases, not a production accuracy estimate. pytest: 59 passed</a:t>
             </a:r>
           </a:p>
         </p:txBody>

</xml_diff>

<commit_message>
updated the presentation documents to align with the current flow of the app
</commit_message>
<xml_diff>
--- a/docs/presentation/Risk_Assessment_Workbench_Genius_Hacks_2026.pptx
+++ b/docs/presentation/Risk_Assessment_Workbench_Genius_Hacks_2026.pptx
@@ -421,28 +421,28 @@
                 <c:formatCode>General</c:formatCode>
                 <c:ptCount val="8"/>
                 <c:pt idx="0">
-                  <c:v>80</c:v>
+                  <c:v>100</c:v>
                 </c:pt>
                 <c:pt idx="1">
-                  <c:v>70</c:v>
+                  <c:v>100</c:v>
                 </c:pt>
                 <c:pt idx="2">
-                  <c:v>70</c:v>
+                  <c:v>100</c:v>
                 </c:pt>
                 <c:pt idx="3">
-                  <c:v>60</c:v>
+                  <c:v>100</c:v>
                 </c:pt>
                 <c:pt idx="4">
-                  <c:v>50</c:v>
+                  <c:v>100</c:v>
                 </c:pt>
                 <c:pt idx="5">
-                  <c:v>70</c:v>
+                  <c:v>100</c:v>
                 </c:pt>
                 <c:pt idx="6">
-                  <c:v>70</c:v>
+                  <c:v>100</c:v>
                 </c:pt>
                 <c:pt idx="7">
-                  <c:v>70</c:v>
+                  <c:v>100</c:v>
                 </c:pt>
               </c:numCache>
             </c:numRef>
@@ -1082,7 +1082,7 @@
           <a:lstStyle/>
           <a:p>
             <a:r>
-              <a:t>0:20-0:50. State the pain in numbers, then the design stance: nothing is approved or rejected automatically. The brief was half a page; it was expanded into docs/requirements.</a:t>
+              <a:t>0:20-0:50. Attribute the 15-20 business-day current-state figure to the brief and the two-day figure to the brief's target; neither is a measured app result. State the design stance: nothing is automatically approved or rejected.</a:t>
             </a:r>
           </a:p>
         </p:txBody>
@@ -1432,7 +1432,7 @@
           <a:lstStyle/>
           <a:p>
             <a:r>
-              <a:t>4:15-5:15. For each gate say what risk it controls: the analyst gate stops a bad extraction reaching the committee; the committee vote keeps the decision human; audit events answer the examiner months later. Nothing is auto-approved.</a:t>
+              <a:t>4:15-5:15. Every risk level goes through analyst review before committee decision. Explain the resume-after-information-request path and that conditions must be evidenced before analyst closure. The event hash chain and examiner export help reconstruct the record but are not immutable against a database owner.</a:t>
             </a:r>
           </a:p>
         </p:txBody>
@@ -1502,7 +1502,7 @@
           <a:lstStyle/>
           <a:p>
             <a:r>
-              <a:t>5:15-7:45 (about 2.5 minutes). Rehearse this path on the network you will use on the day. If OpenAI is unreachable: play the backup screen recording and show the eval results and passing tests. Say aloud what each role sees.</a:t>
+              <a:t>5:15-7:45 (about 2.5 minutes). Owner uploads, checks required draft fields, and submits. The analyst verifies/corrects with source citations, finalizes, and submits to committee. Use three separate committee identities. For a conditional outcome, show owner evidence followed by analyst closure; end with audit verification/export. If the provider is unavailable, use the recorded evaluation and local tests without implying offline extraction.</a:t>
             </a:r>
           </a:p>
         </p:txBody>
@@ -1572,7 +1572,7 @@
           <a:lstStyle/>
           <a:p>
             <a:r>
-              <a:t>7:45-9:45. Lead with the iteration story: baseline, what was classified as wrong, what changed, new number. Then failure handling: the office-network block, how it was detected (APIConnectionError, 0/8), recovery, and the bounded runtime retry added after testing. Also mention malformed PDFs now return a controlled 422. Token line: gpt-4o-mini, bounded input, per-call latency and token telemetry; quote measured tokens per case from the iteration log.</a:t>
+              <a:t>7:45-9:45. Quote the values generated from the latest recorded PDF evaluation and state that this is only eight synthetic cases. Risk agreement comes from deterministic scoring and does not establish field accuracy. Mention controlled errors for invalid PDFs and provider failures; do not suggest extraction has an offline fallback.</a:t>
             </a:r>
           </a:p>
         </p:txBody>
@@ -5477,7 +5477,7 @@
                 </a:solidFill>
                 <a:latin typeface="Calibri"/>
               </a:rPr>
-              <a:t>Real identity and authorization</a:t>
+              <a:t>Real identity + hardened access</a:t>
             </a:r>
           </a:p>
           <a:p>
@@ -5494,7 +5494,7 @@
                 </a:solidFill>
                 <a:latin typeface="Calibri"/>
               </a:rPr>
-              <a:t>TLS and secrets manager</a:t>
+              <a:t>Approved rules + residual-risk controls</a:t>
             </a:r>
           </a:p>
           <a:p>
@@ -5511,7 +5511,7 @@
                 </a:solidFill>
                 <a:latin typeface="Calibri"/>
               </a:rPr>
-              <a:t>Migrations and backups</a:t>
+              <a:t>Protected storage + external audit anchor</a:t>
             </a:r>
           </a:p>
           <a:p>
@@ -5528,7 +5528,7 @@
                 </a:solidFill>
                 <a:latin typeface="Calibri"/>
               </a:rPr>
-              <a:t>Alerts and rollback</a:t>
+              <a:t>Migrations, backups, alerts, rollback</a:t>
             </a:r>
           </a:p>
         </p:txBody>
@@ -5847,7 +5847,7 @@
                 </a:solidFill>
                 <a:latin typeface="Calibri"/>
               </a:rPr>
-              <a:t>business days per assessment today</a:t>
+              <a:t>business days: brief estimate</a:t>
             </a:r>
           </a:p>
         </p:txBody>
@@ -5917,7 +5917,7 @@
                 </a:solidFill>
                 <a:latin typeface="Calibri"/>
               </a:rPr>
-              <a:t>days to decision-ready: the target in the brief</a:t>
+              <a:t>days: brief target, not measured</a:t>
             </a:r>
           </a:p>
         </p:txBody>
@@ -10594,7 +10594,7 @@
                 </a:solidFill>
                 <a:latin typeface="Calibri"/>
               </a:rPr>
-              <a:t>Draft</a:t>
+              <a:t>Owner draft</a:t>
             </a:r>
           </a:p>
         </p:txBody>
@@ -10712,7 +10712,7 @@
                 </a:solidFill>
                 <a:latin typeface="Calibri"/>
               </a:rPr>
-              <a:t>Edit</a:t>
+              <a:t>Analyst review</a:t>
             </a:r>
           </a:p>
         </p:txBody>
@@ -10830,7 +10830,7 @@
                 </a:solidFill>
                 <a:latin typeface="Calibri"/>
               </a:rPr>
-              <a:t>Finalize</a:t>
+              <a:t>Committee</a:t>
             </a:r>
           </a:p>
         </p:txBody>
@@ -10948,7 +10948,7 @@
                 </a:solidFill>
                 <a:latin typeface="Calibri"/>
               </a:rPr>
-              <a:t>Committee</a:t>
+              <a:t>Decision</a:t>
             </a:r>
           </a:p>
         </p:txBody>
@@ -11066,7 +11066,7 @@
                 </a:solidFill>
                 <a:latin typeface="Calibri"/>
               </a:rPr>
-              <a:t>Decision</a:t>
+              <a:t>Close</a:t>
             </a:r>
           </a:p>
         </p:txBody>
@@ -11270,7 +11270,7 @@
                 </a:solidFill>
                 <a:latin typeface="Calibri"/>
               </a:rPr>
-              <a:t>Accept or reject the draft</a:t>
+              <a:t>Every risk level reviewed</a:t>
             </a:r>
           </a:p>
           <a:p>
@@ -11287,7 +11287,7 @@
                 </a:solidFill>
                 <a:latin typeface="Calibri"/>
               </a:rPr>
-              <a:t>Edit and rescore</a:t>
+              <a:t>Edit/rescore with source citations</a:t>
             </a:r>
           </a:p>
           <a:p>
@@ -11304,7 +11304,7 @@
                 </a:solidFill>
                 <a:latin typeface="Calibri"/>
               </a:rPr>
-              <a:t>Rationale required</a:t>
+              <a:t>Finalize with rationale</a:t>
             </a:r>
           </a:p>
         </p:txBody>
@@ -11468,7 +11468,7 @@
                 </a:solidFill>
                 <a:latin typeface="Calibri"/>
               </a:rPr>
-              <a:t>Committee rule</a:t>
+              <a:t>Committee + lifecycle</a:t>
             </a:r>
           </a:p>
         </p:txBody>
@@ -11508,7 +11508,7 @@
                 </a:solidFill>
                 <a:latin typeface="Calibri"/>
               </a:rPr>
-              <a:t>Three distinct votes required</a:t>
+              <a:t>Three distinct votes; 2-vote majority</a:t>
             </a:r>
           </a:p>
           <a:p>
@@ -11525,7 +11525,7 @@
                 </a:solidFill>
                 <a:latin typeface="Calibri"/>
               </a:rPr>
-              <a:t>Approve / reject / defer / conditions</a:t>
+              <a:t>Information requests resume prior stage</a:t>
             </a:r>
           </a:p>
           <a:p>
@@ -11542,7 +11542,7 @@
                 </a:solidFill>
                 <a:latin typeface="Calibri"/>
               </a:rPr>
-              <a:t>Two approvals/rejections decide; otherwise defer</a:t>
+              <a:t>Conditions block closure; reassessments link</a:t>
             </a:r>
           </a:p>
         </p:txBody>
@@ -11746,7 +11746,7 @@
                 </a:solidFill>
                 <a:latin typeface="Calibri"/>
               </a:rPr>
-              <a:t>UTC timestamps</a:t>
+              <a:t>Versioned extractions and UTC events</a:t>
             </a:r>
           </a:p>
           <a:p>
@@ -11763,7 +11763,7 @@
                 </a:solidFill>
                 <a:latin typeface="Calibri"/>
               </a:rPr>
-              <a:t>Append-only workflow events</a:t>
+              <a:t>Verifiable event hash chain + source hashes</a:t>
             </a:r>
           </a:p>
           <a:p>
@@ -11780,7 +11780,7 @@
                 </a:solidFill>
                 <a:latin typeface="Calibri"/>
               </a:rPr>
-              <a:t>Original and edited versions kept</a:t>
+              <a:t>Examiner ZIP with verification manifest</a:t>
             </a:r>
           </a:p>
         </p:txBody>
@@ -11815,7 +11815,7 @@
                 </a:solidFill>
                 <a:latin typeface="Calibri"/>
               </a:rPr>
-              <a:t>Prototype only: demo identity, voting rule not approved as institutional policy, storage not tamper-proof.</a:t>
+              <a:t>Demo identities only; vote/scoring rules are unapproved. Hash-chain verification is not immutable storage.</a:t>
             </a:r>
           </a:p>
         </p:txBody>
@@ -12132,7 +12132,7 @@
                 </a:solidFill>
                 <a:latin typeface="Calibri"/>
               </a:rPr>
-              <a:t>Sign in as product-owner-1</a:t>
+              <a:t>Owner uploads PDF</a:t>
             </a:r>
           </a:p>
         </p:txBody>
@@ -12248,7 +12248,7 @@
                 </a:solidFill>
                 <a:latin typeface="Calibri"/>
               </a:rPr>
-              <a:t>Upload synthetic PDF</a:t>
+              <a:t>Inspect draft + score</a:t>
             </a:r>
           </a:p>
         </p:txBody>
@@ -12364,7 +12364,7 @@
                 </a:solidFill>
                 <a:latin typeface="Calibri"/>
               </a:rPr>
-              <a:t>Inspect fields and score</a:t>
+              <a:t>Owner submits case</a:t>
             </a:r>
           </a:p>
         </p:txBody>
@@ -12480,7 +12480,7 @@
                 </a:solidFill>
                 <a:latin typeface="Calibri"/>
               </a:rPr>
-              <a:t>Switch to analyst-1</a:t>
+              <a:t>Analyst finalizes</a:t>
             </a:r>
           </a:p>
         </p:txBody>
@@ -12596,7 +12596,7 @@
                 </a:solidFill>
                 <a:latin typeface="Calibri"/>
               </a:rPr>
-              <a:t>Finalize with rationale</a:t>
+              <a:t>Three committee votes</a:t>
             </a:r>
           </a:p>
         </p:txBody>
@@ -12712,7 +12712,7 @@
                 </a:solidFill>
                 <a:latin typeface="Calibri"/>
               </a:rPr>
-              <a:t>Three committee votes</a:t>
+              <a:t>Owner evidence; analyst closes</a:t>
             </a:r>
           </a:p>
         </p:txBody>
@@ -12830,7 +12830,7 @@
                 </a:solidFill>
                 <a:latin typeface="Calibri"/>
               </a:rPr>
-              <a:t>Synthetic data only. Demo identity is not production authentication, and the upload endpoint is not role-gated. Extraction needs the OpenAI API and has no offline fallback.</a:t>
+              <a:t>Workflow routes check fixed demo roles, not production identities. Extraction needs the configured model provider; no offline extraction fallback. Source and audit hashes are verifiable, not immutable.</a:t>
             </a:r>
           </a:p>
         </p:txBody>
@@ -13197,7 +13197,7 @@
                 </a:solidFill>
                 <a:latin typeface="Cambria"/>
               </a:rPr>
-              <a:t>67.5%</a:t>
+              <a:t>100.0%</a:t>
             </a:r>
           </a:p>
         </p:txBody>
@@ -13232,7 +13232,7 @@
                 </a:solidFill>
                 <a:latin typeface="Calibri"/>
               </a:rPr>
-              <a:t>field accuracy (54/80)</a:t>
+              <a:t>field accuracy (80/80)</a:t>
             </a:r>
           </a:p>
         </p:txBody>
@@ -13433,7 +13433,7 @@
                 </a:solidFill>
                 <a:latin typeface="Cambria"/>
               </a:rPr>
-              <a:t>2.8 s</a:t>
+              <a:t>3.6 s</a:t>
             </a:r>
           </a:p>
         </p:txBody>
@@ -13609,7 +13609,7 @@
                 </a:solidFill>
                 <a:latin typeface="Calibri"/>
               </a:rPr>
-              <a:t>Office-network incident: 0/8; recovered on an unblocked network. Runtime now retries transient provider failures up to three times</a:t>
+              <a:t>Invalid PDFs and provider failures return explicit errors; transient provider failures are retried up to three times</a:t>
             </a:r>
           </a:p>
           <a:p>
@@ -13643,7 +13643,7 @@
                 </a:solidFill>
                 <a:latin typeface="Calibri"/>
               </a:rPr>
-              <a:t>Eight synthetic cases, not a production accuracy estimate. pytest: 62 passed</a:t>
+              <a:t>Eight synthetic cases, not a production accuracy estimate. pytest: 89 passed</a:t>
             </a:r>
           </a:p>
         </p:txBody>

</xml_diff>

<commit_message>
updated presentation, improving UI
</commit_message>
<xml_diff>
--- a/docs/presentation/Risk_Assessment_Workbench_Genius_Hacks_2026.pptx
+++ b/docs/presentation/Risk_Assessment_Workbench_Genius_Hacks_2026.pptx
@@ -1577,7 +1577,7 @@
           <a:lstStyle/>
           <a:p>
             <a:r>
-              <a:t>2:50-3:30. Deterministic versus probabilistic, justified. Be upfront that the weights are a prototype choice awaiting FCRM approval.</a:t>
+              <a:t>3:00-3:30. Deterministic versus probabilistic, justified. Be upfront that the weights are a prototype choice awaiting FCRM approval.</a:t>
             </a:r>
           </a:p>
         </p:txBody>
@@ -1717,7 +1717,7 @@
           <a:lstStyle/>
           <a:p>
             <a:r>
-              <a:t>4:15-5:15. Every risk level goes through analyst review before committee decision. Explain the resume-after-information-request path and that conditions must be evidenced before analyst closure. The event hash chain and examiner export help reconstruct the record but are not immutable against a database owner.</a:t>
+              <a:t>4:15-5:00. Every risk level goes through analyst review before committee decision. Explain the resume-after-information-request path and that conditions must be evidenced before analyst closure. The event hash chain and examiner export help reconstruct the record but are not immutable against a database owner.</a:t>
             </a:r>
           </a:p>
         </p:txBody>
@@ -6367,7 +6367,7 @@
         <p:spPr>
           <a:xfrm>
             <a:off x="640080" y="1783080"/>
-            <a:ext cx="5074920" cy="4343400"/>
+            <a:ext cx="5074920" cy="3931920"/>
           </a:xfrm>
           <a:prstGeom prst="roundRect">
             <a:avLst>
@@ -6450,7 +6450,7 @@
         <p:spPr>
           <a:xfrm>
             <a:off x="960119" y="2697480"/>
-            <a:ext cx="4434840" cy="3200400"/>
+            <a:ext cx="4434840" cy="2743200"/>
           </a:xfrm>
           <a:prstGeom prst="rect">
             <a:avLst/>
@@ -6541,7 +6541,7 @@
         <p:spPr>
           <a:xfrm>
             <a:off x="6126480" y="1783080"/>
-            <a:ext cx="5422392" cy="4343400"/>
+            <a:ext cx="5422392" cy="3931920"/>
           </a:xfrm>
           <a:prstGeom prst="roundRect">
             <a:avLst>
@@ -7297,7 +7297,7 @@
         <p:spPr>
           <a:xfrm>
             <a:off x="6766560" y="5349240"/>
-            <a:ext cx="4507992" cy="347472"/>
+            <a:ext cx="4507992" cy="274320"/>
           </a:xfrm>
           <a:prstGeom prst="rect">
             <a:avLst/>
@@ -7331,7 +7331,7 @@
         </p:nvSpPr>
         <p:spPr>
           <a:xfrm>
-            <a:off x="640080" y="5852160"/>
+            <a:off x="640080" y="5870448"/>
             <a:ext cx="10908792" cy="292608"/>
           </a:xfrm>
           <a:prstGeom prst="rect">
@@ -7449,7 +7449,7 @@
                 </a:solidFill>
                 <a:latin typeface="Arial"/>
               </a:rPr>
-              <a:t>Budget and telemetry exist; measured cost comparison does not</a:t>
+              <a:t>Token use: budgeted and tracked, not yet measured</a:t>
             </a:r>
           </a:p>
         </p:txBody>
@@ -9687,7 +9687,7 @@
         <p:spPr>
           <a:xfrm>
             <a:off x="640080" y="1783080"/>
-            <a:ext cx="3392423" cy="4343400"/>
+            <a:ext cx="3392423" cy="3931920"/>
           </a:xfrm>
           <a:prstGeom prst="roundRect">
             <a:avLst>
@@ -9777,7 +9777,7 @@
         <p:spPr>
           <a:xfrm>
             <a:off x="960119" y="2834639"/>
-            <a:ext cx="2752344" cy="3017520"/>
+            <a:ext cx="2752344" cy="2743200"/>
           </a:xfrm>
           <a:prstGeom prst="rect">
             <a:avLst/>
@@ -9851,7 +9851,7 @@
         <p:spPr>
           <a:xfrm>
             <a:off x="4398264" y="1783080"/>
-            <a:ext cx="3392423" cy="4343400"/>
+            <a:ext cx="3392423" cy="3931920"/>
           </a:xfrm>
           <a:prstGeom prst="roundRect">
             <a:avLst>
@@ -9941,7 +9941,7 @@
         <p:spPr>
           <a:xfrm>
             <a:off x="4718303" y="2834639"/>
-            <a:ext cx="2752344" cy="3017520"/>
+            <a:ext cx="2752344" cy="2743200"/>
           </a:xfrm>
           <a:prstGeom prst="rect">
             <a:avLst/>
@@ -9984,7 +9984,7 @@
                 </a:solidFill>
                 <a:latin typeface="Calibri"/>
               </a:rPr>
-              <a:t>Draft -&gt; analyst -&gt; committee -&gt; follow-up workflow</a:t>
+              <a:t>Draft → analyst → committee → follow-up workflow</a:t>
             </a:r>
           </a:p>
           <a:p>
@@ -10015,7 +10015,7 @@
         <p:spPr>
           <a:xfrm>
             <a:off x="8156447" y="1783080"/>
-            <a:ext cx="3392423" cy="4343400"/>
+            <a:ext cx="3392423" cy="3931920"/>
           </a:xfrm>
           <a:prstGeom prst="roundRect">
             <a:avLst>
@@ -10105,7 +10105,7 @@
         <p:spPr>
           <a:xfrm>
             <a:off x="8476487" y="2834639"/>
-            <a:ext cx="2752344" cy="3017520"/>
+            <a:ext cx="2752344" cy="2743200"/>
           </a:xfrm>
           <a:prstGeom prst="rect">
             <a:avLst/>
@@ -10178,8 +10178,8 @@
         </p:nvSpPr>
         <p:spPr>
           <a:xfrm>
-            <a:off x="640080" y="5806440"/>
-            <a:ext cx="10908792" cy="384048"/>
+            <a:off x="640080" y="5870448"/>
+            <a:ext cx="10908792" cy="292608"/>
           </a:xfrm>
           <a:prstGeom prst="rect">
             <a:avLst/>

</xml_diff>

<commit_message>
updated to have more accurate details
</commit_message>
<xml_diff>
--- a/docs/presentation/Risk_Assessment_Workbench_Genius_Hacks_2026.pptx
+++ b/docs/presentation/Risk_Assessment_Workbench_Genius_Hacks_2026.pptx
@@ -1647,7 +1647,7 @@
           <a:lstStyle/>
           <a:p>
             <a:r>
-              <a:t>3:30-4:15. One line per stage, naming the artifact: docs/requirements, docs/architecture, src and ai, tests and evals, ops. Point to docs/sdlc/ai-delivery-evidence.md. Move fast; the repo carries the detail.</a:t>
+              <a:t>3:30-4:15. One line per stage, naming the artifact: docs/requirements, docs/architecture, src and ai, tests and evals, ops. Be precise on Operations: the app records telemetry and evaluation results; people review them and have used findings to improve prompts, retries, and tests. There is no AI-powered monitoring or automated alerting. Point to docs/sdlc/ai-delivery-evidence.md. Move fast; the repo carries the detail.</a:t>
             </a:r>
           </a:p>
         </p:txBody>
@@ -13082,7 +13082,7 @@
                 </a:solidFill>
                 <a:latin typeface="Arial"/>
               </a:rPr>
-              <a:t>AI is part of delivery, not only runtime code</a:t>
+              <a:t>AI assists delivery; operations remain human-led</a:t>
             </a:r>
           </a:p>
         </p:txBody>
@@ -14376,7 +14376,7 @@
                 </a:solidFill>
                 <a:latin typeface="Calibri"/>
               </a:rPr>
-              <a:t>Telemetry → feedback</a:t>
+              <a:t>People review telemetry</a:t>
             </a:r>
           </a:p>
         </p:txBody>
@@ -14457,7 +14457,7 @@
                 </a:solidFill>
                 <a:latin typeface="Calibri"/>
               </a:rPr>
-              <a:t>Each stage has an AI instruction, a human gate, and a repository artifact.</a:t>
+              <a:t>AI-assisted delivery is human-reviewed and backed by repository evidence.</a:t>
             </a:r>
           </a:p>
         </p:txBody>

</xml_diff>

<commit_message>
updated docs to contains accurate details
</commit_message>
<xml_diff>
--- a/docs/presentation/Risk_Assessment_Workbench_Genius_Hacks_2026.pptx
+++ b/docs/presentation/Risk_Assessment_Workbench_Genius_Hacks_2026.pptx
@@ -1647,7 +1647,7 @@
           <a:lstStyle/>
           <a:p>
             <a:r>
-              <a:t>3:30-4:15. One line per stage, naming the artifact: docs/requirements, docs/architecture, src and ai, tests and evals, ops. Be precise on Operations: the app records telemetry and evaluation results; people review them and have used findings to improve prompts, retries, and tests. There is no AI-powered monitoring or automated alerting. Point to docs/sdlc/ai-delivery-evidence.md. Move fast; the repo carries the detail.</a:t>
+              <a:t>3:30-4:15. One line per stage, naming the artifact: docs/requirements, docs/architecture, src and ai, tests and evals, ops. Operations now includes an implemented analyst-requested AI review on /intake/telemetry. It uses aggregate metrics from up to 200 recent non-review operations, returns findings with checked metric references and suggested human checks, and records its own provider usage when returned. People verify the interpretation and decide what to change. No case documents are sent for this review. There is no scheduled monitoring, automated alerting, or automatic remediation. Missing token usage, retry-attempt costs, and historical trends cannot be inferred. Validation uses mocked provider responses; live-provider review quality has not been evaluated. Point to docs/sdlc/ai-delivery-evidence.md. Move fast; the repo carries the detail.</a:t>
             </a:r>
           </a:p>
         </p:txBody>
@@ -6187,7 +6187,7 @@
                 </a:solidFill>
                 <a:latin typeface="Calibri"/>
               </a:rPr>
-              <a:t>Local test suite: 91 passed</a:t>
+              <a:t>Local test suite: 99 passed</a:t>
             </a:r>
           </a:p>
         </p:txBody>
@@ -13082,7 +13082,7 @@
                 </a:solidFill>
                 <a:latin typeface="Arial"/>
               </a:rPr>
-              <a:t>AI assists delivery; operations remain human-led</a:t>
+              <a:t>AI assists delivery and operations; people decide</a:t>
             </a:r>
           </a:p>
         </p:txBody>
@@ -14376,7 +14376,7 @@
                 </a:solidFill>
                 <a:latin typeface="Calibri"/>
               </a:rPr>
-              <a:t>People review telemetry</a:t>
+              <a:t>Analyst-requested AI review</a:t>
             </a:r>
           </a:p>
         </p:txBody>

</xml_diff>